<commit_message>
Add 'Assistant IA · Claude' as 6th block in stack tech slide
Stack slide had 5 blocs (code/source/déploiement/db/services). Adding
Claude as a 6th to acknowledge the AI assistance that enabled the
non-dev workflow — consistent with the 'la barrière a chuté' narrative
in slide 14.

Layout tightened to fit:
- card height 0.55 → 0.5
- card gap 0.1 → 0.08
- intro shrunk to 1 line + 1pt smaller
- start y pushed up from 3.5 to 3.1
- footer narrowed (1.2 inch margin) to leave room for page number

Just 'Claude' as the tool — no plan/version mentioned.

Co-Authored-By: Claude Opus 4.7 (1M context) <noreply@anthropic.com>
</commit_message>
<xml_diff>
--- a/docs/pulse-presentation.pptx
+++ b/docs/pulse-presentation.pptx
@@ -9761,24 +9761,24 @@
         </p:nvSpPr>
         <p:spPr>
           <a:xfrm>
-            <a:off x="640080" y="2286000"/>
-            <a:ext cx="10881360" cy="640080"/>
-          </a:xfrm>
-          <a:prstGeom prst="rect">
-            <a:avLst/>
-          </a:prstGeom>
-          <a:noFill/>
-          <a:ln/>
-        </p:spPr>
-        <p:txBody>
-          <a:bodyPr wrap="square" lIns="0" tIns="0" rIns="0" bIns="0" rtlCol="0" anchor="ctr"/>
-          <a:lstStyle/>
-          <a:p>
-            <a:pPr indent="0" marL="0">
-              <a:buNone/>
-            </a:pPr>
-            <a:r>
-              <a:rPr lang="en-US" sz="1600" i="1" dirty="0">
+            <a:off x="640080" y="2194560"/>
+            <a:ext cx="10881360" cy="502920"/>
+          </a:xfrm>
+          <a:prstGeom prst="rect">
+            <a:avLst/>
+          </a:prstGeom>
+          <a:noFill/>
+          <a:ln/>
+        </p:spPr>
+        <p:txBody>
+          <a:bodyPr wrap="square" lIns="0" tIns="0" rIns="0" bIns="0" rtlCol="0" anchor="ctr"/>
+          <a:lstStyle/>
+          <a:p>
+            <a:pPr indent="0" marL="0">
+              <a:buNone/>
+            </a:pPr>
+            <a:r>
+              <a:rPr lang="en-US" sz="1500" i="1" dirty="0">
                 <a:solidFill>
                   <a:srgbClr val="5A5A5A"/>
                 </a:solidFill>
@@ -9786,9 +9786,9 @@
                 <a:ea typeface="Helvetica Neue" pitchFamily="34" charset="-122"/>
                 <a:cs typeface="Helvetica Neue" pitchFamily="34" charset="-120"/>
               </a:rPr>
-              <a:t>Cinq blocs qui s'emboîtent : du code source jusqu'à l'app en ligne, plus les services qui font le sale boulot.</a:t>
-            </a:r>
-            <a:endParaRPr lang="en-US" sz="1600" dirty="0"/>
+              <a:t>Six blocs qui s'emboîtent : du code source jusqu'à l'app en ligne, plus les services et l'assistant qui ont accéléré toute la chaîne.</a:t>
+            </a:r>
+            <a:endParaRPr lang="en-US" sz="1500" dirty="0"/>
           </a:p>
         </p:txBody>
       </p:sp>
@@ -9800,8 +9800,8 @@
         </p:nvSpPr>
         <p:spPr>
           <a:xfrm>
-            <a:off x="640080" y="3200400"/>
-            <a:ext cx="10881360" cy="502920"/>
+            <a:off x="640080" y="2834640"/>
+            <a:ext cx="10881360" cy="457200"/>
           </a:xfrm>
           <a:prstGeom prst="rect">
             <a:avLst/>
@@ -9825,8 +9825,8 @@
         </p:nvSpPr>
         <p:spPr>
           <a:xfrm>
-            <a:off x="640080" y="3200400"/>
-            <a:ext cx="54864" cy="502920"/>
+            <a:off x="640080" y="2834640"/>
+            <a:ext cx="54864" cy="457200"/>
           </a:xfrm>
           <a:prstGeom prst="rect">
             <a:avLst/>
@@ -9850,8 +9850,8 @@
         </p:nvSpPr>
         <p:spPr>
           <a:xfrm>
-            <a:off x="822960" y="3200400"/>
-            <a:ext cx="2560320" cy="502920"/>
+            <a:off x="822960" y="2834640"/>
+            <a:ext cx="2560320" cy="457200"/>
           </a:xfrm>
           <a:prstGeom prst="rect">
             <a:avLst/>
@@ -9889,8 +9889,8 @@
         </p:nvSpPr>
         <p:spPr>
           <a:xfrm>
-            <a:off x="3474720" y="3200400"/>
-            <a:ext cx="3017520" cy="502920"/>
+            <a:off x="3474720" y="2834640"/>
+            <a:ext cx="3017520" cy="457200"/>
           </a:xfrm>
           <a:prstGeom prst="rect">
             <a:avLst/>
@@ -9928,8 +9928,8 @@
         </p:nvSpPr>
         <p:spPr>
           <a:xfrm>
-            <a:off x="6583680" y="3200400"/>
-            <a:ext cx="4754880" cy="502920"/>
+            <a:off x="6583680" y="2834640"/>
+            <a:ext cx="4754880" cy="457200"/>
           </a:xfrm>
           <a:prstGeom prst="rect">
             <a:avLst/>
@@ -9967,8 +9967,8 @@
         </p:nvSpPr>
         <p:spPr>
           <a:xfrm>
-            <a:off x="640080" y="3794760"/>
-            <a:ext cx="10881360" cy="502920"/>
+            <a:off x="640080" y="3364992"/>
+            <a:ext cx="10881360" cy="457200"/>
           </a:xfrm>
           <a:prstGeom prst="rect">
             <a:avLst/>
@@ -9992,8 +9992,8 @@
         </p:nvSpPr>
         <p:spPr>
           <a:xfrm>
-            <a:off x="640080" y="3794760"/>
-            <a:ext cx="54864" cy="502920"/>
+            <a:off x="640080" y="3364992"/>
+            <a:ext cx="54864" cy="457200"/>
           </a:xfrm>
           <a:prstGeom prst="rect">
             <a:avLst/>
@@ -10017,8 +10017,8 @@
         </p:nvSpPr>
         <p:spPr>
           <a:xfrm>
-            <a:off x="822960" y="3794760"/>
-            <a:ext cx="2560320" cy="502920"/>
+            <a:off x="822960" y="3364992"/>
+            <a:ext cx="2560320" cy="457200"/>
           </a:xfrm>
           <a:prstGeom prst="rect">
             <a:avLst/>
@@ -10056,8 +10056,8 @@
         </p:nvSpPr>
         <p:spPr>
           <a:xfrm>
-            <a:off x="3474720" y="3794760"/>
-            <a:ext cx="3017520" cy="502920"/>
+            <a:off x="3474720" y="3364992"/>
+            <a:ext cx="3017520" cy="457200"/>
           </a:xfrm>
           <a:prstGeom prst="rect">
             <a:avLst/>
@@ -10095,8 +10095,8 @@
         </p:nvSpPr>
         <p:spPr>
           <a:xfrm>
-            <a:off x="6583680" y="3794760"/>
-            <a:ext cx="4754880" cy="502920"/>
+            <a:off x="6583680" y="3364992"/>
+            <a:ext cx="4754880" cy="457200"/>
           </a:xfrm>
           <a:prstGeom prst="rect">
             <a:avLst/>
@@ -10134,8 +10134,8 @@
         </p:nvSpPr>
         <p:spPr>
           <a:xfrm>
-            <a:off x="640080" y="4389120"/>
-            <a:ext cx="10881360" cy="502920"/>
+            <a:off x="640080" y="3895344"/>
+            <a:ext cx="10881360" cy="457200"/>
           </a:xfrm>
           <a:prstGeom prst="rect">
             <a:avLst/>
@@ -10159,8 +10159,8 @@
         </p:nvSpPr>
         <p:spPr>
           <a:xfrm>
-            <a:off x="640080" y="4389120"/>
-            <a:ext cx="54864" cy="502920"/>
+            <a:off x="640080" y="3895344"/>
+            <a:ext cx="54864" cy="457200"/>
           </a:xfrm>
           <a:prstGeom prst="rect">
             <a:avLst/>
@@ -10184,8 +10184,8 @@
         </p:nvSpPr>
         <p:spPr>
           <a:xfrm>
-            <a:off x="822960" y="4389120"/>
-            <a:ext cx="2560320" cy="502920"/>
+            <a:off x="822960" y="3895344"/>
+            <a:ext cx="2560320" cy="457200"/>
           </a:xfrm>
           <a:prstGeom prst="rect">
             <a:avLst/>
@@ -10223,8 +10223,8 @@
         </p:nvSpPr>
         <p:spPr>
           <a:xfrm>
-            <a:off x="3474720" y="4389120"/>
-            <a:ext cx="3017520" cy="502920"/>
+            <a:off x="3474720" y="3895344"/>
+            <a:ext cx="3017520" cy="457200"/>
           </a:xfrm>
           <a:prstGeom prst="rect">
             <a:avLst/>
@@ -10262,8 +10262,8 @@
         </p:nvSpPr>
         <p:spPr>
           <a:xfrm>
-            <a:off x="6583680" y="4389120"/>
-            <a:ext cx="4754880" cy="502920"/>
+            <a:off x="6583680" y="3895344"/>
+            <a:ext cx="4754880" cy="457200"/>
           </a:xfrm>
           <a:prstGeom prst="rect">
             <a:avLst/>
@@ -10301,8 +10301,8 @@
         </p:nvSpPr>
         <p:spPr>
           <a:xfrm>
-            <a:off x="640080" y="4983480"/>
-            <a:ext cx="10881360" cy="502920"/>
+            <a:off x="640080" y="4425696"/>
+            <a:ext cx="10881360" cy="457200"/>
           </a:xfrm>
           <a:prstGeom prst="rect">
             <a:avLst/>
@@ -10326,8 +10326,8 @@
         </p:nvSpPr>
         <p:spPr>
           <a:xfrm>
-            <a:off x="640080" y="4983480"/>
-            <a:ext cx="54864" cy="502920"/>
+            <a:off x="640080" y="4425696"/>
+            <a:ext cx="54864" cy="457200"/>
           </a:xfrm>
           <a:prstGeom prst="rect">
             <a:avLst/>
@@ -10351,8 +10351,8 @@
         </p:nvSpPr>
         <p:spPr>
           <a:xfrm>
-            <a:off x="822960" y="4983480"/>
-            <a:ext cx="2560320" cy="502920"/>
+            <a:off x="822960" y="4425696"/>
+            <a:ext cx="2560320" cy="457200"/>
           </a:xfrm>
           <a:prstGeom prst="rect">
             <a:avLst/>
@@ -10390,8 +10390,8 @@
         </p:nvSpPr>
         <p:spPr>
           <a:xfrm>
-            <a:off x="3474720" y="4983480"/>
-            <a:ext cx="3017520" cy="502920"/>
+            <a:off x="3474720" y="4425696"/>
+            <a:ext cx="3017520" cy="457200"/>
           </a:xfrm>
           <a:prstGeom prst="rect">
             <a:avLst/>
@@ -10429,8 +10429,8 @@
         </p:nvSpPr>
         <p:spPr>
           <a:xfrm>
-            <a:off x="6583680" y="4983480"/>
-            <a:ext cx="4754880" cy="502920"/>
+            <a:off x="6583680" y="4425696"/>
+            <a:ext cx="4754880" cy="457200"/>
           </a:xfrm>
           <a:prstGeom prst="rect">
             <a:avLst/>
@@ -10468,8 +10468,8 @@
         </p:nvSpPr>
         <p:spPr>
           <a:xfrm>
-            <a:off x="640080" y="5577840"/>
-            <a:ext cx="10881360" cy="502920"/>
+            <a:off x="640080" y="4956048"/>
+            <a:ext cx="10881360" cy="457200"/>
           </a:xfrm>
           <a:prstGeom prst="rect">
             <a:avLst/>
@@ -10493,8 +10493,8 @@
         </p:nvSpPr>
         <p:spPr>
           <a:xfrm>
-            <a:off x="640080" y="5577840"/>
-            <a:ext cx="54864" cy="502920"/>
+            <a:off x="640080" y="4956048"/>
+            <a:ext cx="54864" cy="457200"/>
           </a:xfrm>
           <a:prstGeom prst="rect">
             <a:avLst/>
@@ -10518,8 +10518,8 @@
         </p:nvSpPr>
         <p:spPr>
           <a:xfrm>
-            <a:off x="822960" y="5577840"/>
-            <a:ext cx="2560320" cy="502920"/>
+            <a:off x="822960" y="4956048"/>
+            <a:ext cx="2560320" cy="457200"/>
           </a:xfrm>
           <a:prstGeom prst="rect">
             <a:avLst/>
@@ -10557,8 +10557,8 @@
         </p:nvSpPr>
         <p:spPr>
           <a:xfrm>
-            <a:off x="3474720" y="5577840"/>
-            <a:ext cx="3017520" cy="502920"/>
+            <a:off x="3474720" y="4956048"/>
+            <a:ext cx="3017520" cy="457200"/>
           </a:xfrm>
           <a:prstGeom prst="rect">
             <a:avLst/>
@@ -10596,8 +10596,8 @@
         </p:nvSpPr>
         <p:spPr>
           <a:xfrm>
-            <a:off x="6583680" y="5577840"/>
-            <a:ext cx="4754880" cy="502920"/>
+            <a:off x="6583680" y="4956048"/>
+            <a:ext cx="4754880" cy="457200"/>
           </a:xfrm>
           <a:prstGeom prst="rect">
             <a:avLst/>
@@ -10629,30 +10629,197 @@
       </p:sp>
       <p:sp>
         <p:nvSpPr>
-          <p:cNvPr id="31" name="Text 29"/>
-          <p:cNvSpPr/>
-          <p:nvPr/>
-        </p:nvSpPr>
-        <p:spPr>
-          <a:xfrm>
-            <a:off x="640080" y="5943600"/>
-            <a:ext cx="10881360" cy="365760"/>
-          </a:xfrm>
-          <a:prstGeom prst="rect">
-            <a:avLst/>
-          </a:prstGeom>
-          <a:noFill/>
-          <a:ln/>
-        </p:spPr>
-        <p:txBody>
-          <a:bodyPr wrap="square" lIns="0" tIns="0" rIns="0" bIns="0" rtlCol="0" anchor="ctr"/>
-          <a:lstStyle/>
-          <a:p>
-            <a:pPr indent="0" marL="0">
-              <a:buNone/>
-            </a:pPr>
-            <a:r>
-              <a:rPr lang="en-US" sz="1200" i="1" dirty="0">
+          <p:cNvPr id="31" name="Shape 29"/>
+          <p:cNvSpPr/>
+          <p:nvPr/>
+        </p:nvSpPr>
+        <p:spPr>
+          <a:xfrm>
+            <a:off x="640080" y="5486400"/>
+            <a:ext cx="10881360" cy="457200"/>
+          </a:xfrm>
+          <a:prstGeom prst="rect">
+            <a:avLst/>
+          </a:prstGeom>
+          <a:solidFill>
+            <a:srgbClr val="F7F7F5"/>
+          </a:solidFill>
+          <a:ln w="12700">
+            <a:solidFill>
+              <a:srgbClr val="D8D8D5"/>
+            </a:solidFill>
+            <a:prstDash val="solid"/>
+          </a:ln>
+        </p:spPr>
+      </p:sp>
+      <p:sp>
+        <p:nvSpPr>
+          <p:cNvPr id="32" name="Shape 30"/>
+          <p:cNvSpPr/>
+          <p:nvPr/>
+        </p:nvSpPr>
+        <p:spPr>
+          <a:xfrm>
+            <a:off x="640080" y="5486400"/>
+            <a:ext cx="54864" cy="457200"/>
+          </a:xfrm>
+          <a:prstGeom prst="rect">
+            <a:avLst/>
+          </a:prstGeom>
+          <a:solidFill>
+            <a:srgbClr val="1A1A1A"/>
+          </a:solidFill>
+          <a:ln w="12700">
+            <a:solidFill>
+              <a:srgbClr val="1A1A1A"/>
+            </a:solidFill>
+            <a:prstDash val="solid"/>
+          </a:ln>
+        </p:spPr>
+      </p:sp>
+      <p:sp>
+        <p:nvSpPr>
+          <p:cNvPr id="33" name="Text 31"/>
+          <p:cNvSpPr/>
+          <p:nvPr/>
+        </p:nvSpPr>
+        <p:spPr>
+          <a:xfrm>
+            <a:off x="822960" y="5486400"/>
+            <a:ext cx="2560320" cy="457200"/>
+          </a:xfrm>
+          <a:prstGeom prst="rect">
+            <a:avLst/>
+          </a:prstGeom>
+          <a:noFill/>
+          <a:ln/>
+        </p:spPr>
+        <p:txBody>
+          <a:bodyPr wrap="square" lIns="0" tIns="0" rIns="0" bIns="0" rtlCol="0" anchor="ctr"/>
+          <a:lstStyle/>
+          <a:p>
+            <a:pPr indent="0" marL="0">
+              <a:buNone/>
+            </a:pPr>
+            <a:r>
+              <a:rPr lang="en-US" sz="1300" b="1" dirty="0">
+                <a:solidFill>
+                  <a:srgbClr val="1A1A1A"/>
+                </a:solidFill>
+                <a:latin typeface="Helvetica Neue" pitchFamily="34" charset="0"/>
+                <a:ea typeface="Helvetica Neue" pitchFamily="34" charset="-122"/>
+                <a:cs typeface="Helvetica Neue" pitchFamily="34" charset="-120"/>
+              </a:rPr>
+              <a:t>Assistant IA</a:t>
+            </a:r>
+            <a:endParaRPr lang="en-US" sz="1300" dirty="0"/>
+          </a:p>
+        </p:txBody>
+      </p:sp>
+      <p:sp>
+        <p:nvSpPr>
+          <p:cNvPr id="34" name="Text 32"/>
+          <p:cNvSpPr/>
+          <p:nvPr/>
+        </p:nvSpPr>
+        <p:spPr>
+          <a:xfrm>
+            <a:off x="3474720" y="5486400"/>
+            <a:ext cx="3017520" cy="457200"/>
+          </a:xfrm>
+          <a:prstGeom prst="rect">
+            <a:avLst/>
+          </a:prstGeom>
+          <a:noFill/>
+          <a:ln/>
+        </p:spPr>
+        <p:txBody>
+          <a:bodyPr wrap="square" lIns="0" tIns="0" rIns="0" bIns="0" rtlCol="0" anchor="ctr"/>
+          <a:lstStyle/>
+          <a:p>
+            <a:pPr indent="0" marL="0">
+              <a:buNone/>
+            </a:pPr>
+            <a:r>
+              <a:rPr lang="en-US" sz="1100" dirty="0">
+                <a:solidFill>
+                  <a:srgbClr val="5A5A5A"/>
+                </a:solidFill>
+                <a:latin typeface="Helvetica Neue" pitchFamily="34" charset="0"/>
+                <a:ea typeface="Helvetica Neue" pitchFamily="34" charset="-122"/>
+                <a:cs typeface="Helvetica Neue" pitchFamily="34" charset="-120"/>
+              </a:rPr>
+              <a:t>Claude</a:t>
+            </a:r>
+            <a:endParaRPr lang="en-US" sz="1100" dirty="0"/>
+          </a:p>
+        </p:txBody>
+      </p:sp>
+      <p:sp>
+        <p:nvSpPr>
+          <p:cNvPr id="35" name="Text 33"/>
+          <p:cNvSpPr/>
+          <p:nvPr/>
+        </p:nvSpPr>
+        <p:spPr>
+          <a:xfrm>
+            <a:off x="6583680" y="5486400"/>
+            <a:ext cx="4754880" cy="457200"/>
+          </a:xfrm>
+          <a:prstGeom prst="rect">
+            <a:avLst/>
+          </a:prstGeom>
+          <a:noFill/>
+          <a:ln/>
+        </p:spPr>
+        <p:txBody>
+          <a:bodyPr wrap="square" lIns="0" tIns="0" rIns="0" bIns="0" rtlCol="0" anchor="ctr"/>
+          <a:lstStyle/>
+          <a:p>
+            <a:pPr indent="0" marL="0">
+              <a:buNone/>
+            </a:pPr>
+            <a:r>
+              <a:rPr lang="en-US" sz="1100" dirty="0">
+                <a:solidFill>
+                  <a:srgbClr val="404040"/>
+                </a:solidFill>
+                <a:latin typeface="Helvetica Neue" pitchFamily="34" charset="0"/>
+                <a:ea typeface="Helvetica Neue" pitchFamily="34" charset="-122"/>
+                <a:cs typeface="Helvetica Neue" pitchFamily="34" charset="-120"/>
+              </a:rPr>
+              <a:t>Génération de code, refactor, audit, debug. L'outil qui a fait chuter le ticket d'entrée pour un non-dev.</a:t>
+            </a:r>
+            <a:endParaRPr lang="en-US" sz="1100" dirty="0"/>
+          </a:p>
+        </p:txBody>
+      </p:sp>
+      <p:sp>
+        <p:nvSpPr>
+          <p:cNvPr id="36" name="Text 34"/>
+          <p:cNvSpPr/>
+          <p:nvPr/>
+        </p:nvSpPr>
+        <p:spPr>
+          <a:xfrm>
+            <a:off x="640080" y="6080760"/>
+            <a:ext cx="9784080" cy="320040"/>
+          </a:xfrm>
+          <a:prstGeom prst="rect">
+            <a:avLst/>
+          </a:prstGeom>
+          <a:noFill/>
+          <a:ln/>
+        </p:spPr>
+        <p:txBody>
+          <a:bodyPr wrap="square" lIns="0" tIns="0" rIns="0" bIns="0" rtlCol="0" anchor="ctr"/>
+          <a:lstStyle/>
+          <a:p>
+            <a:pPr indent="0" marL="0">
+              <a:buNone/>
+            </a:pPr>
+            <a:r>
+              <a:rPr lang="en-US" sz="1100" i="1" dirty="0">
                 <a:solidFill>
                   <a:srgbClr val="8A8A8A"/>
                 </a:solidFill>
@@ -10662,13 +10829,13 @@
               </a:rPr>
               <a:t>Tout est gratuit (free tiers), connecté avec quelques clics dans des dashboards.</a:t>
             </a:r>
-            <a:endParaRPr lang="en-US" sz="1200" dirty="0"/>
-          </a:p>
-        </p:txBody>
-      </p:sp>
-      <p:sp>
-        <p:nvSpPr>
-          <p:cNvPr id="32" name="Text 30"/>
+            <a:endParaRPr lang="en-US" sz="1100" dirty="0"/>
+          </a:p>
+        </p:txBody>
+      </p:sp>
+      <p:sp>
+        <p:nvSpPr>
+          <p:cNvPr id="37" name="Text 35"/>
           <p:cNvSpPr/>
           <p:nvPr/>
         </p:nvSpPr>

</xml_diff>

<commit_message>
Align deck timeline labels with user's Keynote edits (POC / MVP / actuel)
Slide 14 timeline previously labeled the 3 milestones as "Premier
signup réussi" / "V1 polishée" / "Pulse complet". User adopted clearer
product-lifecycle labels in their Keynote working copy:

- ~1h   → POC          (le core tourne end-to-end)
- ~3h30 → MVP          (prêt pour de vrais users)
- ~12h  → Produit actuel (sur 4 jours calendaires)

Aligning the .mjs source so a regenerate doesn't overwrite the labels.

Co-Authored-By: Claude Opus 4.7 (1M context) <noreply@anthropic.com>
</commit_message>
<xml_diff>
--- a/docs/pulse-presentation.pptx
+++ b/docs/pulse-presentation.pptx
@@ -7337,7 +7337,7 @@
                 <a:ea typeface="Helvetica Neue" pitchFamily="34" charset="-122"/>
                 <a:cs typeface="Helvetica Neue" pitchFamily="34" charset="-120"/>
               </a:rPr>
-              <a:t>Premier signup réussi</a:t>
+              <a:t>POC</a:t>
             </a:r>
             <a:endParaRPr lang="en-US" sz="1200" dirty="0"/>
           </a:p>
@@ -7376,7 +7376,7 @@
                 <a:ea typeface="Helvetica Neue" pitchFamily="34" charset="-122"/>
                 <a:cs typeface="Helvetica Neue" pitchFamily="34" charset="-120"/>
               </a:rPr>
-              <a:t>(prep + code)</a:t>
+              <a:t>(le core tourne end-to-end)</a:t>
             </a:r>
             <a:endParaRPr lang="en-US" sz="1000" dirty="0"/>
           </a:p>
@@ -7479,7 +7479,7 @@
                 <a:ea typeface="Helvetica Neue" pitchFamily="34" charset="-122"/>
                 <a:cs typeface="Helvetica Neue" pitchFamily="34" charset="-120"/>
               </a:rPr>
-              <a:t>V1 polishée</a:t>
+              <a:t>MVP</a:t>
             </a:r>
             <a:endParaRPr lang="en-US" sz="1200" dirty="0"/>
           </a:p>
@@ -7518,7 +7518,7 @@
                 <a:ea typeface="Helvetica Neue" pitchFamily="34" charset="-122"/>
                 <a:cs typeface="Helvetica Neue" pitchFamily="34" charset="-120"/>
               </a:rPr>
-              <a:t>(landing, filtres, toasts)</a:t>
+              <a:t>(prêt pour de vrais users)</a:t>
             </a:r>
             <a:endParaRPr lang="en-US" sz="1000" dirty="0"/>
           </a:p>
@@ -7621,7 +7621,7 @@
                 <a:ea typeface="Helvetica Neue" pitchFamily="34" charset="-122"/>
                 <a:cs typeface="Helvetica Neue" pitchFamily="34" charset="-120"/>
               </a:rPr>
-              <a:t>Pulse complet</a:t>
+              <a:t>Produit actuel</a:t>
             </a:r>
             <a:endParaRPr lang="en-US" sz="1200" dirty="0"/>
           </a:p>

</xml_diff>

<commit_message>
Switch deck palette to red-dominant
Replaces the monochromatic charcoal-on-white palette with a
red-dominant scheme. Body text stays warm charcoal (readability)
while every decorative element becomes red:

- Title underlines, vertical accent stripes on cards, bullet ovals,
  card top-stripes, timeline dots, Q&A horizontal line → red-700
  (#B91C1C, professional medium red)

- Large surfaces (section break backgrounds, the Vercel hub on the
  architecture diagram, the "Coder direct + IA" highlight card) →
  red-900 (#7F1D1D, deeper red) for sobriety

- Light backgrounds and borders get a slight warm pink tint
  (#FBF4F5, #ECD9DB) so the whole deck reads "in the red family"
  without screaming

- bgPaper stays pure white, mutedLight stays neutral gray

The structure of every slide is unchanged — only colors swap.

Co-Authored-By: Claude Opus 4.7 (1M context) <noreply@anthropic.com>
</commit_message>
<xml_diff>
--- a/docs/pulse-presentation.pptx
+++ b/docs/pulse-presentation.pptx
@@ -2237,7 +2237,7 @@
             <a:r>
               <a:rPr lang="en-US" sz="1100" b="1" spc="800" kern="0" dirty="0">
                 <a:solidFill>
-                  <a:srgbClr val="8A8A8A"/>
+                  <a:srgbClr val="9A8889"/>
                 </a:solidFill>
                 <a:latin typeface="Helvetica Neue" pitchFamily="34" charset="0"/>
                 <a:ea typeface="Helvetica Neue" pitchFamily="34" charset="-122"/>
@@ -2276,7 +2276,7 @@
             <a:r>
               <a:rPr lang="en-US" sz="4800" b="1" dirty="0">
                 <a:solidFill>
-                  <a:srgbClr val="1A1A1A"/>
+                  <a:srgbClr val="1F1213"/>
                 </a:solidFill>
                 <a:latin typeface="Helvetica Neue" pitchFamily="34" charset="0"/>
                 <a:ea typeface="Helvetica Neue" pitchFamily="34" charset="-122"/>
@@ -2315,7 +2315,7 @@
             <a:r>
               <a:rPr lang="en-US" sz="1600" dirty="0">
                 <a:solidFill>
-                  <a:srgbClr val="5A5A5A"/>
+                  <a:srgbClr val="6B5557"/>
                 </a:solidFill>
                 <a:latin typeface="Helvetica Neue" pitchFamily="34" charset="0"/>
                 <a:ea typeface="Helvetica Neue" pitchFamily="34" charset="-122"/>
@@ -2354,7 +2354,7 @@
             <a:r>
               <a:rPr lang="en-US" sz="1300" b="1" dirty="0">
                 <a:solidFill>
-                  <a:srgbClr val="1A1A1A"/>
+                  <a:srgbClr val="1F1213"/>
                 </a:solidFill>
                 <a:latin typeface="Helvetica Neue" pitchFamily="34" charset="0"/>
                 <a:ea typeface="Helvetica Neue" pitchFamily="34" charset="-122"/>
@@ -2393,7 +2393,7 @@
             <a:r>
               <a:rPr lang="en-US" sz="1100" dirty="0">
                 <a:solidFill>
-                  <a:srgbClr val="8A8A8A"/>
+                  <a:srgbClr val="9A8889"/>
                 </a:solidFill>
                 <a:latin typeface="Helvetica Neue" pitchFamily="34" charset="0"/>
                 <a:ea typeface="Helvetica Neue" pitchFamily="34" charset="-122"/>
@@ -2419,7 +2419,7 @@
     <p:bg>
       <p:bgPr>
         <a:solidFill>
-          <a:srgbClr val="1A1A1A"/>
+          <a:srgbClr val="7F1D1D"/>
         </a:solidFill>
       </p:bgPr>
     </p:bg>
@@ -2464,7 +2464,7 @@
             <a:r>
               <a:rPr lang="en-US" sz="1100" b="1" spc="800" kern="0" dirty="0">
                 <a:solidFill>
-                  <a:srgbClr val="8A8A8A"/>
+                  <a:srgbClr val="9A8889"/>
                 </a:solidFill>
                 <a:latin typeface="Helvetica Neue" pitchFamily="34" charset="0"/>
                 <a:ea typeface="Helvetica Neue" pitchFamily="34" charset="-122"/>
@@ -2613,7 +2613,7 @@
             <a:r>
               <a:rPr lang="en-US" sz="900" spc="400" kern="0" dirty="0">
                 <a:solidFill>
-                  <a:srgbClr val="8A8A8A"/>
+                  <a:srgbClr val="9A8889"/>
                 </a:solidFill>
                 <a:latin typeface="Helvetica Neue" pitchFamily="34" charset="0"/>
                 <a:ea typeface="Helvetica Neue" pitchFamily="34" charset="-122"/>
@@ -2652,7 +2652,7 @@
             <a:r>
               <a:rPr lang="en-US" sz="3600" b="1" dirty="0">
                 <a:solidFill>
-                  <a:srgbClr val="1A1A1A"/>
+                  <a:srgbClr val="1F1213"/>
                 </a:solidFill>
                 <a:latin typeface="Helvetica Neue" pitchFamily="34" charset="0"/>
                 <a:ea typeface="Helvetica Neue" pitchFamily="34" charset="-122"/>
@@ -2681,7 +2681,7 @@
           <a:noFill/>
           <a:ln w="19050">
             <a:solidFill>
-              <a:srgbClr val="1A1A1A"/>
+              <a:srgbClr val="B91C1C"/>
             </a:solidFill>
             <a:prstDash val="solid"/>
           </a:ln>
@@ -2714,7 +2714,7 @@
             <a:r>
               <a:rPr lang="en-US" sz="1700" i="1" dirty="0">
                 <a:solidFill>
-                  <a:srgbClr val="5A5A5A"/>
+                  <a:srgbClr val="6B5557"/>
                 </a:solidFill>
                 <a:latin typeface="Helvetica Neue" pitchFamily="34" charset="0"/>
                 <a:ea typeface="Helvetica Neue" pitchFamily="34" charset="-122"/>
@@ -2741,11 +2741,11 @@
             <a:avLst/>
           </a:prstGeom>
           <a:solidFill>
-            <a:srgbClr val="1A1A1A"/>
+            <a:srgbClr val="B91C1C"/>
           </a:solidFill>
           <a:ln w="12700">
             <a:solidFill>
-              <a:srgbClr val="1A1A1A"/>
+              <a:srgbClr val="1F1213"/>
             </a:solidFill>
             <a:prstDash val="solid"/>
           </a:ln>
@@ -2778,7 +2778,7 @@
             <a:r>
               <a:rPr lang="en-US" sz="1500" b="1" dirty="0">
                 <a:solidFill>
-                  <a:srgbClr val="1A1A1A"/>
+                  <a:srgbClr val="1F1213"/>
                 </a:solidFill>
                 <a:latin typeface="Helvetica Neue" pitchFamily="34" charset="0"/>
                 <a:ea typeface="Helvetica Neue" pitchFamily="34" charset="-122"/>
@@ -2792,7 +2792,7 @@
             <a:r>
               <a:rPr lang="en-US" sz="1500" dirty="0">
                 <a:solidFill>
-                  <a:srgbClr val="404040"/>
+                  <a:srgbClr val="3A2628"/>
                 </a:solidFill>
                 <a:latin typeface="Helvetica Neue" pitchFamily="34" charset="0"/>
                 <a:ea typeface="Helvetica Neue" pitchFamily="34" charset="-122"/>
@@ -2819,11 +2819,11 @@
             <a:avLst/>
           </a:prstGeom>
           <a:solidFill>
-            <a:srgbClr val="1A1A1A"/>
+            <a:srgbClr val="B91C1C"/>
           </a:solidFill>
           <a:ln w="12700">
             <a:solidFill>
-              <a:srgbClr val="1A1A1A"/>
+              <a:srgbClr val="1F1213"/>
             </a:solidFill>
             <a:prstDash val="solid"/>
           </a:ln>
@@ -2856,7 +2856,7 @@
             <a:r>
               <a:rPr lang="en-US" sz="1500" b="1" dirty="0">
                 <a:solidFill>
-                  <a:srgbClr val="1A1A1A"/>
+                  <a:srgbClr val="1F1213"/>
                 </a:solidFill>
                 <a:latin typeface="Helvetica Neue" pitchFamily="34" charset="0"/>
                 <a:ea typeface="Helvetica Neue" pitchFamily="34" charset="-122"/>
@@ -2870,7 +2870,7 @@
             <a:r>
               <a:rPr lang="en-US" sz="1500" dirty="0">
                 <a:solidFill>
-                  <a:srgbClr val="404040"/>
+                  <a:srgbClr val="3A2628"/>
                 </a:solidFill>
                 <a:latin typeface="Helvetica Neue" pitchFamily="34" charset="0"/>
                 <a:ea typeface="Helvetica Neue" pitchFamily="34" charset="-122"/>
@@ -2897,11 +2897,11 @@
             <a:avLst/>
           </a:prstGeom>
           <a:solidFill>
-            <a:srgbClr val="1A1A1A"/>
+            <a:srgbClr val="B91C1C"/>
           </a:solidFill>
           <a:ln w="12700">
             <a:solidFill>
-              <a:srgbClr val="1A1A1A"/>
+              <a:srgbClr val="1F1213"/>
             </a:solidFill>
             <a:prstDash val="solid"/>
           </a:ln>
@@ -2934,7 +2934,7 @@
             <a:r>
               <a:rPr lang="en-US" sz="1500" b="1" dirty="0">
                 <a:solidFill>
-                  <a:srgbClr val="1A1A1A"/>
+                  <a:srgbClr val="1F1213"/>
                 </a:solidFill>
                 <a:latin typeface="Helvetica Neue" pitchFamily="34" charset="0"/>
                 <a:ea typeface="Helvetica Neue" pitchFamily="34" charset="-122"/>
@@ -2948,7 +2948,7 @@
             <a:r>
               <a:rPr lang="en-US" sz="1500" dirty="0">
                 <a:solidFill>
-                  <a:srgbClr val="404040"/>
+                  <a:srgbClr val="3A2628"/>
                 </a:solidFill>
                 <a:latin typeface="Helvetica Neue" pitchFamily="34" charset="0"/>
                 <a:ea typeface="Helvetica Neue" pitchFamily="34" charset="-122"/>
@@ -2987,7 +2987,7 @@
             <a:r>
               <a:rPr lang="en-US" sz="1300" b="1" i="1" dirty="0">
                 <a:solidFill>
-                  <a:srgbClr val="1A1A1A"/>
+                  <a:srgbClr val="1F1213"/>
                 </a:solidFill>
                 <a:latin typeface="Helvetica Neue" pitchFamily="34" charset="0"/>
                 <a:ea typeface="Helvetica Neue" pitchFamily="34" charset="-122"/>
@@ -3026,7 +3026,7 @@
             <a:r>
               <a:rPr lang="en-US" sz="900" dirty="0">
                 <a:solidFill>
-                  <a:srgbClr val="8A8A8A"/>
+                  <a:srgbClr val="9A8889"/>
                 </a:solidFill>
                 <a:latin typeface="Helvetica Neue" pitchFamily="34" charset="0"/>
                 <a:ea typeface="Helvetica Neue" pitchFamily="34" charset="-122"/>
@@ -3097,7 +3097,7 @@
             <a:r>
               <a:rPr lang="en-US" sz="900" spc="400" kern="0" dirty="0">
                 <a:solidFill>
-                  <a:srgbClr val="8A8A8A"/>
+                  <a:srgbClr val="9A8889"/>
                 </a:solidFill>
                 <a:latin typeface="Helvetica Neue" pitchFamily="34" charset="0"/>
                 <a:ea typeface="Helvetica Neue" pitchFamily="34" charset="-122"/>
@@ -3136,7 +3136,7 @@
             <a:r>
               <a:rPr lang="en-US" sz="3600" b="1" dirty="0">
                 <a:solidFill>
-                  <a:srgbClr val="1A1A1A"/>
+                  <a:srgbClr val="1F1213"/>
                 </a:solidFill>
                 <a:latin typeface="Helvetica Neue" pitchFamily="34" charset="0"/>
                 <a:ea typeface="Helvetica Neue" pitchFamily="34" charset="-122"/>
@@ -3165,7 +3165,7 @@
           <a:noFill/>
           <a:ln w="19050">
             <a:solidFill>
-              <a:srgbClr val="1A1A1A"/>
+              <a:srgbClr val="B91C1C"/>
             </a:solidFill>
             <a:prstDash val="solid"/>
           </a:ln>
@@ -3198,7 +3198,7 @@
             <a:r>
               <a:rPr lang="en-US" sz="1600" i="1" dirty="0">
                 <a:solidFill>
-                  <a:srgbClr val="5A5A5A"/>
+                  <a:srgbClr val="6B5557"/>
                 </a:solidFill>
                 <a:latin typeface="Helvetica Neue" pitchFamily="34" charset="0"/>
                 <a:ea typeface="Helvetica Neue" pitchFamily="34" charset="-122"/>
@@ -3225,11 +3225,11 @@
             <a:avLst/>
           </a:prstGeom>
           <a:solidFill>
-            <a:srgbClr val="F7F7F5"/>
+            <a:srgbClr val="FBF4F5"/>
           </a:solidFill>
           <a:ln w="12700">
             <a:solidFill>
-              <a:srgbClr val="D8D8D5"/>
+              <a:srgbClr val="ECD9DB"/>
             </a:solidFill>
             <a:prstDash val="solid"/>
           </a:ln>
@@ -3250,11 +3250,11 @@
             <a:avLst/>
           </a:prstGeom>
           <a:solidFill>
-            <a:srgbClr val="1A1A1A"/>
+            <a:srgbClr val="B91C1C"/>
           </a:solidFill>
           <a:ln w="12700">
             <a:solidFill>
-              <a:srgbClr val="1A1A1A"/>
+              <a:srgbClr val="1F1213"/>
             </a:solidFill>
             <a:prstDash val="solid"/>
           </a:ln>
@@ -3287,7 +3287,7 @@
             <a:r>
               <a:rPr lang="en-US" sz="1900" b="1" dirty="0">
                 <a:solidFill>
-                  <a:srgbClr val="1A1A1A"/>
+                  <a:srgbClr val="1F1213"/>
                 </a:solidFill>
                 <a:latin typeface="Helvetica Neue" pitchFamily="34" charset="0"/>
                 <a:ea typeface="Helvetica Neue" pitchFamily="34" charset="-122"/>
@@ -3326,7 +3326,7 @@
             <a:r>
               <a:rPr lang="en-US" sz="1100" b="1" spc="300" kern="0" dirty="0">
                 <a:solidFill>
-                  <a:srgbClr val="8A8A8A"/>
+                  <a:srgbClr val="9A8889"/>
                 </a:solidFill>
                 <a:latin typeface="Helvetica Neue" pitchFamily="34" charset="0"/>
                 <a:ea typeface="Helvetica Neue" pitchFamily="34" charset="-122"/>
@@ -3353,11 +3353,11 @@
             <a:avLst/>
           </a:prstGeom>
           <a:solidFill>
-            <a:srgbClr val="1A1A1A"/>
+            <a:srgbClr val="B91C1C"/>
           </a:solidFill>
           <a:ln w="12700">
             <a:solidFill>
-              <a:srgbClr val="1A1A1A"/>
+              <a:srgbClr val="1F1213"/>
             </a:solidFill>
             <a:prstDash val="solid"/>
           </a:ln>
@@ -3390,7 +3390,7 @@
             <a:r>
               <a:rPr lang="en-US" sz="1050" dirty="0">
                 <a:solidFill>
-                  <a:srgbClr val="404040"/>
+                  <a:srgbClr val="3A2628"/>
                 </a:solidFill>
                 <a:latin typeface="Helvetica Neue" pitchFamily="34" charset="0"/>
                 <a:ea typeface="Helvetica Neue" pitchFamily="34" charset="-122"/>
@@ -3417,11 +3417,11 @@
             <a:avLst/>
           </a:prstGeom>
           <a:solidFill>
-            <a:srgbClr val="1A1A1A"/>
+            <a:srgbClr val="B91C1C"/>
           </a:solidFill>
           <a:ln w="12700">
             <a:solidFill>
-              <a:srgbClr val="1A1A1A"/>
+              <a:srgbClr val="1F1213"/>
             </a:solidFill>
             <a:prstDash val="solid"/>
           </a:ln>
@@ -3454,7 +3454,7 @@
             <a:r>
               <a:rPr lang="en-US" sz="1050" dirty="0">
                 <a:solidFill>
-                  <a:srgbClr val="404040"/>
+                  <a:srgbClr val="3A2628"/>
                 </a:solidFill>
                 <a:latin typeface="Helvetica Neue" pitchFamily="34" charset="0"/>
                 <a:ea typeface="Helvetica Neue" pitchFamily="34" charset="-122"/>
@@ -3481,11 +3481,11 @@
             <a:avLst/>
           </a:prstGeom>
           <a:solidFill>
-            <a:srgbClr val="1A1A1A"/>
+            <a:srgbClr val="B91C1C"/>
           </a:solidFill>
           <a:ln w="12700">
             <a:solidFill>
-              <a:srgbClr val="1A1A1A"/>
+              <a:srgbClr val="1F1213"/>
             </a:solidFill>
             <a:prstDash val="solid"/>
           </a:ln>
@@ -3518,7 +3518,7 @@
             <a:r>
               <a:rPr lang="en-US" sz="1050" dirty="0">
                 <a:solidFill>
-                  <a:srgbClr val="404040"/>
+                  <a:srgbClr val="3A2628"/>
                 </a:solidFill>
                 <a:latin typeface="Helvetica Neue" pitchFamily="34" charset="0"/>
                 <a:ea typeface="Helvetica Neue" pitchFamily="34" charset="-122"/>
@@ -3557,7 +3557,7 @@
             <a:r>
               <a:rPr lang="en-US" sz="1000" b="1" i="1" dirty="0">
                 <a:solidFill>
-                  <a:srgbClr val="5A5A5A"/>
+                  <a:srgbClr val="6B5557"/>
                 </a:solidFill>
                 <a:latin typeface="Helvetica Neue" pitchFamily="34" charset="0"/>
                 <a:ea typeface="Helvetica Neue" pitchFamily="34" charset="-122"/>
@@ -3571,7 +3571,7 @@
             <a:r>
               <a:rPr lang="en-US" sz="1000" i="1" dirty="0">
                 <a:solidFill>
-                  <a:srgbClr val="5A5A5A"/>
+                  <a:srgbClr val="6B5557"/>
                 </a:solidFill>
                 <a:latin typeface="Helvetica Neue" pitchFamily="34" charset="0"/>
                 <a:ea typeface="Helvetica Neue" pitchFamily="34" charset="-122"/>
@@ -3598,11 +3598,11 @@
             <a:avLst/>
           </a:prstGeom>
           <a:solidFill>
-            <a:srgbClr val="F7F7F5"/>
+            <a:srgbClr val="FBF4F5"/>
           </a:solidFill>
           <a:ln w="12700">
             <a:solidFill>
-              <a:srgbClr val="D8D8D5"/>
+              <a:srgbClr val="ECD9DB"/>
             </a:solidFill>
             <a:prstDash val="solid"/>
           </a:ln>
@@ -3623,11 +3623,11 @@
             <a:avLst/>
           </a:prstGeom>
           <a:solidFill>
-            <a:srgbClr val="1A1A1A"/>
+            <a:srgbClr val="B91C1C"/>
           </a:solidFill>
           <a:ln w="12700">
             <a:solidFill>
-              <a:srgbClr val="1A1A1A"/>
+              <a:srgbClr val="1F1213"/>
             </a:solidFill>
             <a:prstDash val="solid"/>
           </a:ln>
@@ -3660,7 +3660,7 @@
             <a:r>
               <a:rPr lang="en-US" sz="1900" b="1" dirty="0">
                 <a:solidFill>
-                  <a:srgbClr val="1A1A1A"/>
+                  <a:srgbClr val="1F1213"/>
                 </a:solidFill>
                 <a:latin typeface="Helvetica Neue" pitchFamily="34" charset="0"/>
                 <a:ea typeface="Helvetica Neue" pitchFamily="34" charset="-122"/>
@@ -3699,7 +3699,7 @@
             <a:r>
               <a:rPr lang="en-US" sz="1100" b="1" spc="300" kern="0" dirty="0">
                 <a:solidFill>
-                  <a:srgbClr val="8A8A8A"/>
+                  <a:srgbClr val="9A8889"/>
                 </a:solidFill>
                 <a:latin typeface="Helvetica Neue" pitchFamily="34" charset="0"/>
                 <a:ea typeface="Helvetica Neue" pitchFamily="34" charset="-122"/>
@@ -3726,11 +3726,11 @@
             <a:avLst/>
           </a:prstGeom>
           <a:solidFill>
-            <a:srgbClr val="1A1A1A"/>
+            <a:srgbClr val="B91C1C"/>
           </a:solidFill>
           <a:ln w="12700">
             <a:solidFill>
-              <a:srgbClr val="1A1A1A"/>
+              <a:srgbClr val="1F1213"/>
             </a:solidFill>
             <a:prstDash val="solid"/>
           </a:ln>
@@ -3763,7 +3763,7 @@
             <a:r>
               <a:rPr lang="en-US" sz="1050" dirty="0">
                 <a:solidFill>
-                  <a:srgbClr val="404040"/>
+                  <a:srgbClr val="3A2628"/>
                 </a:solidFill>
                 <a:latin typeface="Helvetica Neue" pitchFamily="34" charset="0"/>
                 <a:ea typeface="Helvetica Neue" pitchFamily="34" charset="-122"/>
@@ -3790,11 +3790,11 @@
             <a:avLst/>
           </a:prstGeom>
           <a:solidFill>
-            <a:srgbClr val="1A1A1A"/>
+            <a:srgbClr val="B91C1C"/>
           </a:solidFill>
           <a:ln w="12700">
             <a:solidFill>
-              <a:srgbClr val="1A1A1A"/>
+              <a:srgbClr val="1F1213"/>
             </a:solidFill>
             <a:prstDash val="solid"/>
           </a:ln>
@@ -3827,7 +3827,7 @@
             <a:r>
               <a:rPr lang="en-US" sz="1050" dirty="0">
                 <a:solidFill>
-                  <a:srgbClr val="404040"/>
+                  <a:srgbClr val="3A2628"/>
                 </a:solidFill>
                 <a:latin typeface="Helvetica Neue" pitchFamily="34" charset="0"/>
                 <a:ea typeface="Helvetica Neue" pitchFamily="34" charset="-122"/>
@@ -3854,11 +3854,11 @@
             <a:avLst/>
           </a:prstGeom>
           <a:solidFill>
-            <a:srgbClr val="1A1A1A"/>
+            <a:srgbClr val="B91C1C"/>
           </a:solidFill>
           <a:ln w="12700">
             <a:solidFill>
-              <a:srgbClr val="1A1A1A"/>
+              <a:srgbClr val="1F1213"/>
             </a:solidFill>
             <a:prstDash val="solid"/>
           </a:ln>
@@ -3891,7 +3891,7 @@
             <a:r>
               <a:rPr lang="en-US" sz="1050" dirty="0">
                 <a:solidFill>
-                  <a:srgbClr val="404040"/>
+                  <a:srgbClr val="3A2628"/>
                 </a:solidFill>
                 <a:latin typeface="Helvetica Neue" pitchFamily="34" charset="0"/>
                 <a:ea typeface="Helvetica Neue" pitchFamily="34" charset="-122"/>
@@ -3930,7 +3930,7 @@
             <a:r>
               <a:rPr lang="en-US" sz="1000" b="1" i="1" dirty="0">
                 <a:solidFill>
-                  <a:srgbClr val="5A5A5A"/>
+                  <a:srgbClr val="6B5557"/>
                 </a:solidFill>
                 <a:latin typeface="Helvetica Neue" pitchFamily="34" charset="0"/>
                 <a:ea typeface="Helvetica Neue" pitchFamily="34" charset="-122"/>
@@ -3944,7 +3944,7 @@
             <a:r>
               <a:rPr lang="en-US" sz="1000" i="1" dirty="0">
                 <a:solidFill>
-                  <a:srgbClr val="5A5A5A"/>
+                  <a:srgbClr val="6B5557"/>
                 </a:solidFill>
                 <a:latin typeface="Helvetica Neue" pitchFamily="34" charset="0"/>
                 <a:ea typeface="Helvetica Neue" pitchFamily="34" charset="-122"/>
@@ -3971,11 +3971,11 @@
             <a:avLst/>
           </a:prstGeom>
           <a:solidFill>
-            <a:srgbClr val="F7F7F5"/>
+            <a:srgbClr val="FBF4F5"/>
           </a:solidFill>
           <a:ln w="12700">
             <a:solidFill>
-              <a:srgbClr val="D8D8D5"/>
+              <a:srgbClr val="ECD9DB"/>
             </a:solidFill>
             <a:prstDash val="solid"/>
           </a:ln>
@@ -3996,11 +3996,11 @@
             <a:avLst/>
           </a:prstGeom>
           <a:solidFill>
-            <a:srgbClr val="1A1A1A"/>
+            <a:srgbClr val="B91C1C"/>
           </a:solidFill>
           <a:ln w="12700">
             <a:solidFill>
-              <a:srgbClr val="1A1A1A"/>
+              <a:srgbClr val="1F1213"/>
             </a:solidFill>
             <a:prstDash val="solid"/>
           </a:ln>
@@ -4033,7 +4033,7 @@
             <a:r>
               <a:rPr lang="en-US" sz="1900" b="1" dirty="0">
                 <a:solidFill>
-                  <a:srgbClr val="1A1A1A"/>
+                  <a:srgbClr val="1F1213"/>
                 </a:solidFill>
                 <a:latin typeface="Helvetica Neue" pitchFamily="34" charset="0"/>
                 <a:ea typeface="Helvetica Neue" pitchFamily="34" charset="-122"/>
@@ -4072,7 +4072,7 @@
             <a:r>
               <a:rPr lang="en-US" sz="1100" b="1" spc="300" kern="0" dirty="0">
                 <a:solidFill>
-                  <a:srgbClr val="8A8A8A"/>
+                  <a:srgbClr val="9A8889"/>
                 </a:solidFill>
                 <a:latin typeface="Helvetica Neue" pitchFamily="34" charset="0"/>
                 <a:ea typeface="Helvetica Neue" pitchFamily="34" charset="-122"/>
@@ -4099,11 +4099,11 @@
             <a:avLst/>
           </a:prstGeom>
           <a:solidFill>
-            <a:srgbClr val="1A1A1A"/>
+            <a:srgbClr val="B91C1C"/>
           </a:solidFill>
           <a:ln w="12700">
             <a:solidFill>
-              <a:srgbClr val="1A1A1A"/>
+              <a:srgbClr val="1F1213"/>
             </a:solidFill>
             <a:prstDash val="solid"/>
           </a:ln>
@@ -4136,7 +4136,7 @@
             <a:r>
               <a:rPr lang="en-US" sz="1050" dirty="0">
                 <a:solidFill>
-                  <a:srgbClr val="404040"/>
+                  <a:srgbClr val="3A2628"/>
                 </a:solidFill>
                 <a:latin typeface="Helvetica Neue" pitchFamily="34" charset="0"/>
                 <a:ea typeface="Helvetica Neue" pitchFamily="34" charset="-122"/>
@@ -4163,11 +4163,11 @@
             <a:avLst/>
           </a:prstGeom>
           <a:solidFill>
-            <a:srgbClr val="1A1A1A"/>
+            <a:srgbClr val="B91C1C"/>
           </a:solidFill>
           <a:ln w="12700">
             <a:solidFill>
-              <a:srgbClr val="1A1A1A"/>
+              <a:srgbClr val="1F1213"/>
             </a:solidFill>
             <a:prstDash val="solid"/>
           </a:ln>
@@ -4200,7 +4200,7 @@
             <a:r>
               <a:rPr lang="en-US" sz="1050" dirty="0">
                 <a:solidFill>
-                  <a:srgbClr val="404040"/>
+                  <a:srgbClr val="3A2628"/>
                 </a:solidFill>
                 <a:latin typeface="Helvetica Neue" pitchFamily="34" charset="0"/>
                 <a:ea typeface="Helvetica Neue" pitchFamily="34" charset="-122"/>
@@ -4227,11 +4227,11 @@
             <a:avLst/>
           </a:prstGeom>
           <a:solidFill>
-            <a:srgbClr val="1A1A1A"/>
+            <a:srgbClr val="B91C1C"/>
           </a:solidFill>
           <a:ln w="12700">
             <a:solidFill>
-              <a:srgbClr val="1A1A1A"/>
+              <a:srgbClr val="1F1213"/>
             </a:solidFill>
             <a:prstDash val="solid"/>
           </a:ln>
@@ -4264,7 +4264,7 @@
             <a:r>
               <a:rPr lang="en-US" sz="1050" dirty="0">
                 <a:solidFill>
-                  <a:srgbClr val="404040"/>
+                  <a:srgbClr val="3A2628"/>
                 </a:solidFill>
                 <a:latin typeface="Helvetica Neue" pitchFamily="34" charset="0"/>
                 <a:ea typeface="Helvetica Neue" pitchFamily="34" charset="-122"/>
@@ -4303,7 +4303,7 @@
             <a:r>
               <a:rPr lang="en-US" sz="1000" b="1" i="1" dirty="0">
                 <a:solidFill>
-                  <a:srgbClr val="5A5A5A"/>
+                  <a:srgbClr val="6B5557"/>
                 </a:solidFill>
                 <a:latin typeface="Helvetica Neue" pitchFamily="34" charset="0"/>
                 <a:ea typeface="Helvetica Neue" pitchFamily="34" charset="-122"/>
@@ -4317,7 +4317,7 @@
             <a:r>
               <a:rPr lang="en-US" sz="1000" i="1" dirty="0">
                 <a:solidFill>
-                  <a:srgbClr val="5A5A5A"/>
+                  <a:srgbClr val="6B5557"/>
                 </a:solidFill>
                 <a:latin typeface="Helvetica Neue" pitchFamily="34" charset="0"/>
                 <a:ea typeface="Helvetica Neue" pitchFamily="34" charset="-122"/>
@@ -4356,7 +4356,7 @@
             <a:r>
               <a:rPr lang="en-US" sz="900" dirty="0">
                 <a:solidFill>
-                  <a:srgbClr val="8A8A8A"/>
+                  <a:srgbClr val="9A8889"/>
                 </a:solidFill>
                 <a:latin typeface="Helvetica Neue" pitchFamily="34" charset="0"/>
                 <a:ea typeface="Helvetica Neue" pitchFamily="34" charset="-122"/>
@@ -4427,7 +4427,7 @@
             <a:r>
               <a:rPr lang="en-US" sz="900" spc="400" kern="0" dirty="0">
                 <a:solidFill>
-                  <a:srgbClr val="8A8A8A"/>
+                  <a:srgbClr val="9A8889"/>
                 </a:solidFill>
                 <a:latin typeface="Helvetica Neue" pitchFamily="34" charset="0"/>
                 <a:ea typeface="Helvetica Neue" pitchFamily="34" charset="-122"/>
@@ -4466,7 +4466,7 @@
             <a:r>
               <a:rPr lang="en-US" sz="3600" b="1" dirty="0">
                 <a:solidFill>
-                  <a:srgbClr val="1A1A1A"/>
+                  <a:srgbClr val="1F1213"/>
                 </a:solidFill>
                 <a:latin typeface="Helvetica Neue" pitchFamily="34" charset="0"/>
                 <a:ea typeface="Helvetica Neue" pitchFamily="34" charset="-122"/>
@@ -4495,7 +4495,7 @@
           <a:noFill/>
           <a:ln w="19050">
             <a:solidFill>
-              <a:srgbClr val="1A1A1A"/>
+              <a:srgbClr val="B91C1C"/>
             </a:solidFill>
             <a:prstDash val="solid"/>
           </a:ln>
@@ -4528,7 +4528,7 @@
             <a:r>
               <a:rPr lang="en-US" sz="1600" i="1" dirty="0">
                 <a:solidFill>
-                  <a:srgbClr val="5A5A5A"/>
+                  <a:srgbClr val="6B5557"/>
                 </a:solidFill>
                 <a:latin typeface="Helvetica Neue" pitchFamily="34" charset="0"/>
                 <a:ea typeface="Helvetica Neue" pitchFamily="34" charset="-122"/>
@@ -4555,11 +4555,11 @@
             <a:avLst/>
           </a:prstGeom>
           <a:solidFill>
-            <a:srgbClr val="F7F7F5"/>
+            <a:srgbClr val="FBF4F5"/>
           </a:solidFill>
           <a:ln w="12700">
             <a:solidFill>
-              <a:srgbClr val="D8D8D5"/>
+              <a:srgbClr val="ECD9DB"/>
             </a:solidFill>
             <a:prstDash val="solid"/>
           </a:ln>
@@ -4580,11 +4580,11 @@
             <a:avLst/>
           </a:prstGeom>
           <a:solidFill>
-            <a:srgbClr val="1A1A1A"/>
+            <a:srgbClr val="B91C1C"/>
           </a:solidFill>
           <a:ln w="12700">
             <a:solidFill>
-              <a:srgbClr val="1A1A1A"/>
+              <a:srgbClr val="1F1213"/>
             </a:solidFill>
             <a:prstDash val="solid"/>
           </a:ln>
@@ -4617,7 +4617,7 @@
             <a:r>
               <a:rPr lang="en-US" sz="1900" b="1" dirty="0">
                 <a:solidFill>
-                  <a:srgbClr val="1A1A1A"/>
+                  <a:srgbClr val="1F1213"/>
                 </a:solidFill>
                 <a:latin typeface="Helvetica Neue" pitchFamily="34" charset="0"/>
                 <a:ea typeface="Helvetica Neue" pitchFamily="34" charset="-122"/>
@@ -4656,7 +4656,7 @@
             <a:r>
               <a:rPr lang="en-US" sz="1100" b="1" spc="300" kern="0" dirty="0">
                 <a:solidFill>
-                  <a:srgbClr val="8A8A8A"/>
+                  <a:srgbClr val="9A8889"/>
                 </a:solidFill>
                 <a:latin typeface="Helvetica Neue" pitchFamily="34" charset="0"/>
                 <a:ea typeface="Helvetica Neue" pitchFamily="34" charset="-122"/>
@@ -4683,11 +4683,11 @@
             <a:avLst/>
           </a:prstGeom>
           <a:solidFill>
-            <a:srgbClr val="1A1A1A"/>
+            <a:srgbClr val="B91C1C"/>
           </a:solidFill>
           <a:ln w="12700">
             <a:solidFill>
-              <a:srgbClr val="1A1A1A"/>
+              <a:srgbClr val="1F1213"/>
             </a:solidFill>
             <a:prstDash val="solid"/>
           </a:ln>
@@ -4720,7 +4720,7 @@
             <a:r>
               <a:rPr lang="en-US" sz="1050" dirty="0">
                 <a:solidFill>
-                  <a:srgbClr val="404040"/>
+                  <a:srgbClr val="3A2628"/>
                 </a:solidFill>
                 <a:latin typeface="Helvetica Neue" pitchFamily="34" charset="0"/>
                 <a:ea typeface="Helvetica Neue" pitchFamily="34" charset="-122"/>
@@ -4747,11 +4747,11 @@
             <a:avLst/>
           </a:prstGeom>
           <a:solidFill>
-            <a:srgbClr val="1A1A1A"/>
+            <a:srgbClr val="B91C1C"/>
           </a:solidFill>
           <a:ln w="12700">
             <a:solidFill>
-              <a:srgbClr val="1A1A1A"/>
+              <a:srgbClr val="1F1213"/>
             </a:solidFill>
             <a:prstDash val="solid"/>
           </a:ln>
@@ -4784,7 +4784,7 @@
             <a:r>
               <a:rPr lang="en-US" sz="1050" dirty="0">
                 <a:solidFill>
-                  <a:srgbClr val="404040"/>
+                  <a:srgbClr val="3A2628"/>
                 </a:solidFill>
                 <a:latin typeface="Helvetica Neue" pitchFamily="34" charset="0"/>
                 <a:ea typeface="Helvetica Neue" pitchFamily="34" charset="-122"/>
@@ -4811,11 +4811,11 @@
             <a:avLst/>
           </a:prstGeom>
           <a:solidFill>
-            <a:srgbClr val="1A1A1A"/>
+            <a:srgbClr val="B91C1C"/>
           </a:solidFill>
           <a:ln w="12700">
             <a:solidFill>
-              <a:srgbClr val="1A1A1A"/>
+              <a:srgbClr val="1F1213"/>
             </a:solidFill>
             <a:prstDash val="solid"/>
           </a:ln>
@@ -4848,7 +4848,7 @@
             <a:r>
               <a:rPr lang="en-US" sz="1050" dirty="0">
                 <a:solidFill>
-                  <a:srgbClr val="404040"/>
+                  <a:srgbClr val="3A2628"/>
                 </a:solidFill>
                 <a:latin typeface="Helvetica Neue" pitchFamily="34" charset="0"/>
                 <a:ea typeface="Helvetica Neue" pitchFamily="34" charset="-122"/>
@@ -4887,7 +4887,7 @@
             <a:r>
               <a:rPr lang="en-US" sz="1000" b="1" i="1" dirty="0">
                 <a:solidFill>
-                  <a:srgbClr val="5A5A5A"/>
+                  <a:srgbClr val="6B5557"/>
                 </a:solidFill>
                 <a:latin typeface="Helvetica Neue" pitchFamily="34" charset="0"/>
                 <a:ea typeface="Helvetica Neue" pitchFamily="34" charset="-122"/>
@@ -4901,7 +4901,7 @@
             <a:r>
               <a:rPr lang="en-US" sz="1000" i="1" dirty="0">
                 <a:solidFill>
-                  <a:srgbClr val="5A5A5A"/>
+                  <a:srgbClr val="6B5557"/>
                 </a:solidFill>
                 <a:latin typeface="Helvetica Neue" pitchFamily="34" charset="0"/>
                 <a:ea typeface="Helvetica Neue" pitchFamily="34" charset="-122"/>
@@ -4928,11 +4928,11 @@
             <a:avLst/>
           </a:prstGeom>
           <a:solidFill>
-            <a:srgbClr val="F7F7F5"/>
+            <a:srgbClr val="FBF4F5"/>
           </a:solidFill>
           <a:ln w="12700">
             <a:solidFill>
-              <a:srgbClr val="D8D8D5"/>
+              <a:srgbClr val="ECD9DB"/>
             </a:solidFill>
             <a:prstDash val="solid"/>
           </a:ln>
@@ -4953,11 +4953,11 @@
             <a:avLst/>
           </a:prstGeom>
           <a:solidFill>
-            <a:srgbClr val="1A1A1A"/>
+            <a:srgbClr val="B91C1C"/>
           </a:solidFill>
           <a:ln w="12700">
             <a:solidFill>
-              <a:srgbClr val="1A1A1A"/>
+              <a:srgbClr val="1F1213"/>
             </a:solidFill>
             <a:prstDash val="solid"/>
           </a:ln>
@@ -4990,7 +4990,7 @@
             <a:r>
               <a:rPr lang="en-US" sz="1900" b="1" dirty="0">
                 <a:solidFill>
-                  <a:srgbClr val="1A1A1A"/>
+                  <a:srgbClr val="1F1213"/>
                 </a:solidFill>
                 <a:latin typeface="Helvetica Neue" pitchFamily="34" charset="0"/>
                 <a:ea typeface="Helvetica Neue" pitchFamily="34" charset="-122"/>
@@ -5029,7 +5029,7 @@
             <a:r>
               <a:rPr lang="en-US" sz="1100" b="1" spc="300" kern="0" dirty="0">
                 <a:solidFill>
-                  <a:srgbClr val="8A8A8A"/>
+                  <a:srgbClr val="9A8889"/>
                 </a:solidFill>
                 <a:latin typeface="Helvetica Neue" pitchFamily="34" charset="0"/>
                 <a:ea typeface="Helvetica Neue" pitchFamily="34" charset="-122"/>
@@ -5056,11 +5056,11 @@
             <a:avLst/>
           </a:prstGeom>
           <a:solidFill>
-            <a:srgbClr val="1A1A1A"/>
+            <a:srgbClr val="B91C1C"/>
           </a:solidFill>
           <a:ln w="12700">
             <a:solidFill>
-              <a:srgbClr val="1A1A1A"/>
+              <a:srgbClr val="1F1213"/>
             </a:solidFill>
             <a:prstDash val="solid"/>
           </a:ln>
@@ -5093,7 +5093,7 @@
             <a:r>
               <a:rPr lang="en-US" sz="1050" dirty="0">
                 <a:solidFill>
-                  <a:srgbClr val="404040"/>
+                  <a:srgbClr val="3A2628"/>
                 </a:solidFill>
                 <a:latin typeface="Helvetica Neue" pitchFamily="34" charset="0"/>
                 <a:ea typeface="Helvetica Neue" pitchFamily="34" charset="-122"/>
@@ -5120,11 +5120,11 @@
             <a:avLst/>
           </a:prstGeom>
           <a:solidFill>
-            <a:srgbClr val="1A1A1A"/>
+            <a:srgbClr val="B91C1C"/>
           </a:solidFill>
           <a:ln w="12700">
             <a:solidFill>
-              <a:srgbClr val="1A1A1A"/>
+              <a:srgbClr val="1F1213"/>
             </a:solidFill>
             <a:prstDash val="solid"/>
           </a:ln>
@@ -5157,7 +5157,7 @@
             <a:r>
               <a:rPr lang="en-US" sz="1050" dirty="0">
                 <a:solidFill>
-                  <a:srgbClr val="404040"/>
+                  <a:srgbClr val="3A2628"/>
                 </a:solidFill>
                 <a:latin typeface="Helvetica Neue" pitchFamily="34" charset="0"/>
                 <a:ea typeface="Helvetica Neue" pitchFamily="34" charset="-122"/>
@@ -5184,11 +5184,11 @@
             <a:avLst/>
           </a:prstGeom>
           <a:solidFill>
-            <a:srgbClr val="1A1A1A"/>
+            <a:srgbClr val="B91C1C"/>
           </a:solidFill>
           <a:ln w="12700">
             <a:solidFill>
-              <a:srgbClr val="1A1A1A"/>
+              <a:srgbClr val="1F1213"/>
             </a:solidFill>
             <a:prstDash val="solid"/>
           </a:ln>
@@ -5221,7 +5221,7 @@
             <a:r>
               <a:rPr lang="en-US" sz="1050" dirty="0">
                 <a:solidFill>
-                  <a:srgbClr val="404040"/>
+                  <a:srgbClr val="3A2628"/>
                 </a:solidFill>
                 <a:latin typeface="Helvetica Neue" pitchFamily="34" charset="0"/>
                 <a:ea typeface="Helvetica Neue" pitchFamily="34" charset="-122"/>
@@ -5260,7 +5260,7 @@
             <a:r>
               <a:rPr lang="en-US" sz="1000" b="1" i="1" dirty="0">
                 <a:solidFill>
-                  <a:srgbClr val="5A5A5A"/>
+                  <a:srgbClr val="6B5557"/>
                 </a:solidFill>
                 <a:latin typeface="Helvetica Neue" pitchFamily="34" charset="0"/>
                 <a:ea typeface="Helvetica Neue" pitchFamily="34" charset="-122"/>
@@ -5274,7 +5274,7 @@
             <a:r>
               <a:rPr lang="en-US" sz="1000" i="1" dirty="0">
                 <a:solidFill>
-                  <a:srgbClr val="5A5A5A"/>
+                  <a:srgbClr val="6B5557"/>
                 </a:solidFill>
                 <a:latin typeface="Helvetica Neue" pitchFamily="34" charset="0"/>
                 <a:ea typeface="Helvetica Neue" pitchFamily="34" charset="-122"/>
@@ -5301,11 +5301,11 @@
             <a:avLst/>
           </a:prstGeom>
           <a:solidFill>
-            <a:srgbClr val="F7F7F5"/>
+            <a:srgbClr val="FBF4F5"/>
           </a:solidFill>
           <a:ln w="12700">
             <a:solidFill>
-              <a:srgbClr val="D8D8D5"/>
+              <a:srgbClr val="ECD9DB"/>
             </a:solidFill>
             <a:prstDash val="solid"/>
           </a:ln>
@@ -5326,11 +5326,11 @@
             <a:avLst/>
           </a:prstGeom>
           <a:solidFill>
-            <a:srgbClr val="1A1A1A"/>
+            <a:srgbClr val="B91C1C"/>
           </a:solidFill>
           <a:ln w="12700">
             <a:solidFill>
-              <a:srgbClr val="1A1A1A"/>
+              <a:srgbClr val="1F1213"/>
             </a:solidFill>
             <a:prstDash val="solid"/>
           </a:ln>
@@ -5363,7 +5363,7 @@
             <a:r>
               <a:rPr lang="en-US" sz="1900" b="1" dirty="0">
                 <a:solidFill>
-                  <a:srgbClr val="1A1A1A"/>
+                  <a:srgbClr val="1F1213"/>
                 </a:solidFill>
                 <a:latin typeface="Helvetica Neue" pitchFamily="34" charset="0"/>
                 <a:ea typeface="Helvetica Neue" pitchFamily="34" charset="-122"/>
@@ -5402,7 +5402,7 @@
             <a:r>
               <a:rPr lang="en-US" sz="1100" b="1" spc="300" kern="0" dirty="0">
                 <a:solidFill>
-                  <a:srgbClr val="8A8A8A"/>
+                  <a:srgbClr val="9A8889"/>
                 </a:solidFill>
                 <a:latin typeface="Helvetica Neue" pitchFamily="34" charset="0"/>
                 <a:ea typeface="Helvetica Neue" pitchFamily="34" charset="-122"/>
@@ -5429,11 +5429,11 @@
             <a:avLst/>
           </a:prstGeom>
           <a:solidFill>
-            <a:srgbClr val="1A1A1A"/>
+            <a:srgbClr val="B91C1C"/>
           </a:solidFill>
           <a:ln w="12700">
             <a:solidFill>
-              <a:srgbClr val="1A1A1A"/>
+              <a:srgbClr val="1F1213"/>
             </a:solidFill>
             <a:prstDash val="solid"/>
           </a:ln>
@@ -5466,7 +5466,7 @@
             <a:r>
               <a:rPr lang="en-US" sz="1050" dirty="0">
                 <a:solidFill>
-                  <a:srgbClr val="404040"/>
+                  <a:srgbClr val="3A2628"/>
                 </a:solidFill>
                 <a:latin typeface="Helvetica Neue" pitchFamily="34" charset="0"/>
                 <a:ea typeface="Helvetica Neue" pitchFamily="34" charset="-122"/>
@@ -5493,11 +5493,11 @@
             <a:avLst/>
           </a:prstGeom>
           <a:solidFill>
-            <a:srgbClr val="1A1A1A"/>
+            <a:srgbClr val="B91C1C"/>
           </a:solidFill>
           <a:ln w="12700">
             <a:solidFill>
-              <a:srgbClr val="1A1A1A"/>
+              <a:srgbClr val="1F1213"/>
             </a:solidFill>
             <a:prstDash val="solid"/>
           </a:ln>
@@ -5530,7 +5530,7 @@
             <a:r>
               <a:rPr lang="en-US" sz="1050" dirty="0">
                 <a:solidFill>
-                  <a:srgbClr val="404040"/>
+                  <a:srgbClr val="3A2628"/>
                 </a:solidFill>
                 <a:latin typeface="Helvetica Neue" pitchFamily="34" charset="0"/>
                 <a:ea typeface="Helvetica Neue" pitchFamily="34" charset="-122"/>
@@ -5557,11 +5557,11 @@
             <a:avLst/>
           </a:prstGeom>
           <a:solidFill>
-            <a:srgbClr val="1A1A1A"/>
+            <a:srgbClr val="B91C1C"/>
           </a:solidFill>
           <a:ln w="12700">
             <a:solidFill>
-              <a:srgbClr val="1A1A1A"/>
+              <a:srgbClr val="1F1213"/>
             </a:solidFill>
             <a:prstDash val="solid"/>
           </a:ln>
@@ -5594,7 +5594,7 @@
             <a:r>
               <a:rPr lang="en-US" sz="1050" dirty="0">
                 <a:solidFill>
-                  <a:srgbClr val="404040"/>
+                  <a:srgbClr val="3A2628"/>
                 </a:solidFill>
                 <a:latin typeface="Helvetica Neue" pitchFamily="34" charset="0"/>
                 <a:ea typeface="Helvetica Neue" pitchFamily="34" charset="-122"/>
@@ -5633,7 +5633,7 @@
             <a:r>
               <a:rPr lang="en-US" sz="1000" b="1" i="1" dirty="0">
                 <a:solidFill>
-                  <a:srgbClr val="5A5A5A"/>
+                  <a:srgbClr val="6B5557"/>
                 </a:solidFill>
                 <a:latin typeface="Helvetica Neue" pitchFamily="34" charset="0"/>
                 <a:ea typeface="Helvetica Neue" pitchFamily="34" charset="-122"/>
@@ -5647,7 +5647,7 @@
             <a:r>
               <a:rPr lang="en-US" sz="1000" i="1" dirty="0">
                 <a:solidFill>
-                  <a:srgbClr val="5A5A5A"/>
+                  <a:srgbClr val="6B5557"/>
                 </a:solidFill>
                 <a:latin typeface="Helvetica Neue" pitchFamily="34" charset="0"/>
                 <a:ea typeface="Helvetica Neue" pitchFamily="34" charset="-122"/>
@@ -5686,7 +5686,7 @@
             <a:r>
               <a:rPr lang="en-US" sz="900" dirty="0">
                 <a:solidFill>
-                  <a:srgbClr val="8A8A8A"/>
+                  <a:srgbClr val="9A8889"/>
                 </a:solidFill>
                 <a:latin typeface="Helvetica Neue" pitchFamily="34" charset="0"/>
                 <a:ea typeface="Helvetica Neue" pitchFamily="34" charset="-122"/>
@@ -5757,7 +5757,7 @@
             <a:r>
               <a:rPr lang="en-US" sz="900" spc="400" kern="0" dirty="0">
                 <a:solidFill>
-                  <a:srgbClr val="8A8A8A"/>
+                  <a:srgbClr val="9A8889"/>
                 </a:solidFill>
                 <a:latin typeface="Helvetica Neue" pitchFamily="34" charset="0"/>
                 <a:ea typeface="Helvetica Neue" pitchFamily="34" charset="-122"/>
@@ -5796,7 +5796,7 @@
             <a:r>
               <a:rPr lang="en-US" sz="3600" b="1" dirty="0">
                 <a:solidFill>
-                  <a:srgbClr val="1A1A1A"/>
+                  <a:srgbClr val="1F1213"/>
                 </a:solidFill>
                 <a:latin typeface="Helvetica Neue" pitchFamily="34" charset="0"/>
                 <a:ea typeface="Helvetica Neue" pitchFamily="34" charset="-122"/>
@@ -5825,7 +5825,7 @@
           <a:noFill/>
           <a:ln w="19050">
             <a:solidFill>
-              <a:srgbClr val="1A1A1A"/>
+              <a:srgbClr val="B91C1C"/>
             </a:solidFill>
             <a:prstDash val="solid"/>
           </a:ln>
@@ -5858,7 +5858,7 @@
             <a:r>
               <a:rPr lang="en-US" sz="1600" i="1" dirty="0">
                 <a:solidFill>
-                  <a:srgbClr val="5A5A5A"/>
+                  <a:srgbClr val="6B5557"/>
                 </a:solidFill>
                 <a:latin typeface="Helvetica Neue" pitchFamily="34" charset="0"/>
                 <a:ea typeface="Helvetica Neue" pitchFamily="34" charset="-122"/>
@@ -5885,11 +5885,11 @@
             <a:avLst/>
           </a:prstGeom>
           <a:solidFill>
-            <a:srgbClr val="1A1A1A"/>
+            <a:srgbClr val="7F1D1D"/>
           </a:solidFill>
           <a:ln w="12700">
             <a:solidFill>
-              <a:srgbClr val="1A1A1A"/>
+              <a:srgbClr val="1F1213"/>
             </a:solidFill>
             <a:prstDash val="solid"/>
           </a:ln>
@@ -6144,11 +6144,11 @@
             <a:avLst/>
           </a:prstGeom>
           <a:solidFill>
-            <a:srgbClr val="F7F7F5"/>
+            <a:srgbClr val="FBF4F5"/>
           </a:solidFill>
           <a:ln w="12700">
             <a:solidFill>
-              <a:srgbClr val="D8D8D5"/>
+              <a:srgbClr val="ECD9DB"/>
             </a:solidFill>
             <a:prstDash val="solid"/>
           </a:ln>
@@ -6181,7 +6181,7 @@
             <a:r>
               <a:rPr lang="en-US" sz="2000" b="1" dirty="0">
                 <a:solidFill>
-                  <a:srgbClr val="1A1A1A"/>
+                  <a:srgbClr val="1F1213"/>
                 </a:solidFill>
                 <a:latin typeface="Helvetica Neue" pitchFamily="34" charset="0"/>
                 <a:ea typeface="Helvetica Neue" pitchFamily="34" charset="-122"/>
@@ -6220,7 +6220,7 @@
             <a:r>
               <a:rPr lang="en-US" sz="1100" dirty="0">
                 <a:solidFill>
-                  <a:srgbClr val="404040"/>
+                  <a:srgbClr val="3A2628"/>
                 </a:solidFill>
                 <a:latin typeface="Helvetica Neue" pitchFamily="34" charset="0"/>
                 <a:ea typeface="Helvetica Neue" pitchFamily="34" charset="-122"/>
@@ -6259,7 +6259,7 @@
             <a:r>
               <a:rPr lang="en-US" sz="1100" dirty="0">
                 <a:solidFill>
-                  <a:srgbClr val="404040"/>
+                  <a:srgbClr val="3A2628"/>
                 </a:solidFill>
                 <a:latin typeface="Helvetica Neue" pitchFamily="34" charset="0"/>
                 <a:ea typeface="Helvetica Neue" pitchFamily="34" charset="-122"/>
@@ -6298,7 +6298,7 @@
             <a:r>
               <a:rPr lang="en-US" sz="1100" dirty="0">
                 <a:solidFill>
-                  <a:srgbClr val="404040"/>
+                  <a:srgbClr val="3A2628"/>
                 </a:solidFill>
                 <a:latin typeface="Helvetica Neue" pitchFamily="34" charset="0"/>
                 <a:ea typeface="Helvetica Neue" pitchFamily="34" charset="-122"/>
@@ -6337,7 +6337,7 @@
             <a:r>
               <a:rPr lang="en-US" sz="1000" dirty="0">
                 <a:solidFill>
-                  <a:srgbClr val="5A5A5A"/>
+                  <a:srgbClr val="6B5557"/>
                 </a:solidFill>
                 <a:latin typeface="Helvetica Neue" pitchFamily="34" charset="0"/>
                 <a:ea typeface="Helvetica Neue" pitchFamily="34" charset="-122"/>
@@ -6376,7 +6376,7 @@
             <a:r>
               <a:rPr lang="en-US" sz="1000" dirty="0">
                 <a:solidFill>
-                  <a:srgbClr val="5A5A5A"/>
+                  <a:srgbClr val="6B5557"/>
                 </a:solidFill>
                 <a:latin typeface="Helvetica Neue" pitchFamily="34" charset="0"/>
                 <a:ea typeface="Helvetica Neue" pitchFamily="34" charset="-122"/>
@@ -6415,7 +6415,7 @@
             <a:r>
               <a:rPr lang="en-US" sz="1000" dirty="0">
                 <a:solidFill>
-                  <a:srgbClr val="5A5A5A"/>
+                  <a:srgbClr val="6B5557"/>
                 </a:solidFill>
                 <a:latin typeface="Helvetica Neue" pitchFamily="34" charset="0"/>
                 <a:ea typeface="Helvetica Neue" pitchFamily="34" charset="-122"/>
@@ -6454,7 +6454,7 @@
             <a:r>
               <a:rPr lang="en-US" sz="1000" dirty="0">
                 <a:solidFill>
-                  <a:srgbClr val="5A5A5A"/>
+                  <a:srgbClr val="6B5557"/>
                 </a:solidFill>
                 <a:latin typeface="Helvetica Neue" pitchFamily="34" charset="0"/>
                 <a:ea typeface="Helvetica Neue" pitchFamily="34" charset="-122"/>
@@ -6493,7 +6493,7 @@
             <a:r>
               <a:rPr lang="en-US" sz="900" dirty="0">
                 <a:solidFill>
-                  <a:srgbClr val="8A8A8A"/>
+                  <a:srgbClr val="9A8889"/>
                 </a:solidFill>
                 <a:latin typeface="Helvetica Neue" pitchFamily="34" charset="0"/>
                 <a:ea typeface="Helvetica Neue" pitchFamily="34" charset="-122"/>
@@ -6564,7 +6564,7 @@
             <a:r>
               <a:rPr lang="en-US" sz="900" spc="400" kern="0" dirty="0">
                 <a:solidFill>
-                  <a:srgbClr val="8A8A8A"/>
+                  <a:srgbClr val="9A8889"/>
                 </a:solidFill>
                 <a:latin typeface="Helvetica Neue" pitchFamily="34" charset="0"/>
                 <a:ea typeface="Helvetica Neue" pitchFamily="34" charset="-122"/>
@@ -6603,7 +6603,7 @@
             <a:r>
               <a:rPr lang="en-US" sz="3600" b="1" dirty="0">
                 <a:solidFill>
-                  <a:srgbClr val="1A1A1A"/>
+                  <a:srgbClr val="1F1213"/>
                 </a:solidFill>
                 <a:latin typeface="Helvetica Neue" pitchFamily="34" charset="0"/>
                 <a:ea typeface="Helvetica Neue" pitchFamily="34" charset="-122"/>
@@ -6632,7 +6632,7 @@
           <a:noFill/>
           <a:ln w="19050">
             <a:solidFill>
-              <a:srgbClr val="1A1A1A"/>
+              <a:srgbClr val="B91C1C"/>
             </a:solidFill>
             <a:prstDash val="solid"/>
           </a:ln>
@@ -6653,11 +6653,11 @@
             <a:avLst/>
           </a:prstGeom>
           <a:solidFill>
-            <a:srgbClr val="F7F7F5"/>
+            <a:srgbClr val="FBF4F5"/>
           </a:solidFill>
           <a:ln w="12700">
             <a:solidFill>
-              <a:srgbClr val="D8D8D5"/>
+              <a:srgbClr val="ECD9DB"/>
             </a:solidFill>
             <a:prstDash val="solid"/>
           </a:ln>
@@ -6678,11 +6678,11 @@
             <a:avLst/>
           </a:prstGeom>
           <a:solidFill>
-            <a:srgbClr val="1A1A1A"/>
+            <a:srgbClr val="B91C1C"/>
           </a:solidFill>
           <a:ln w="12700">
             <a:solidFill>
-              <a:srgbClr val="1A1A1A"/>
+              <a:srgbClr val="1F1213"/>
             </a:solidFill>
             <a:prstDash val="solid"/>
           </a:ln>
@@ -6715,7 +6715,7 @@
             <a:r>
               <a:rPr lang="en-US" sz="1500" b="1" dirty="0">
                 <a:solidFill>
-                  <a:srgbClr val="1A1A1A"/>
+                  <a:srgbClr val="1F1213"/>
                 </a:solidFill>
                 <a:latin typeface="Helvetica Neue" pitchFamily="34" charset="0"/>
                 <a:ea typeface="Helvetica Neue" pitchFamily="34" charset="-122"/>
@@ -6754,7 +6754,7 @@
             <a:r>
               <a:rPr lang="en-US" sz="1000" b="1" spc="300" kern="0" dirty="0">
                 <a:solidFill>
-                  <a:srgbClr val="8A8A8A"/>
+                  <a:srgbClr val="9A8889"/>
                 </a:solidFill>
                 <a:latin typeface="Helvetica Neue" pitchFamily="34" charset="0"/>
                 <a:ea typeface="Helvetica Neue" pitchFamily="34" charset="-122"/>
@@ -6793,7 +6793,7 @@
             <a:r>
               <a:rPr lang="en-US" sz="1050" dirty="0">
                 <a:solidFill>
-                  <a:srgbClr val="404040"/>
+                  <a:srgbClr val="3A2628"/>
                 </a:solidFill>
                 <a:latin typeface="Helvetica Neue" pitchFamily="34" charset="0"/>
                 <a:ea typeface="Helvetica Neue" pitchFamily="34" charset="-122"/>
@@ -6820,11 +6820,11 @@
             <a:avLst/>
           </a:prstGeom>
           <a:solidFill>
-            <a:srgbClr val="F7F7F5"/>
+            <a:srgbClr val="FBF4F5"/>
           </a:solidFill>
           <a:ln w="12700">
             <a:solidFill>
-              <a:srgbClr val="D8D8D5"/>
+              <a:srgbClr val="ECD9DB"/>
             </a:solidFill>
             <a:prstDash val="solid"/>
           </a:ln>
@@ -6845,11 +6845,11 @@
             <a:avLst/>
           </a:prstGeom>
           <a:solidFill>
-            <a:srgbClr val="1A1A1A"/>
+            <a:srgbClr val="B91C1C"/>
           </a:solidFill>
           <a:ln w="12700">
             <a:solidFill>
-              <a:srgbClr val="1A1A1A"/>
+              <a:srgbClr val="1F1213"/>
             </a:solidFill>
             <a:prstDash val="solid"/>
           </a:ln>
@@ -6882,7 +6882,7 @@
             <a:r>
               <a:rPr lang="en-US" sz="1500" b="1" dirty="0">
                 <a:solidFill>
-                  <a:srgbClr val="1A1A1A"/>
+                  <a:srgbClr val="1F1213"/>
                 </a:solidFill>
                 <a:latin typeface="Helvetica Neue" pitchFamily="34" charset="0"/>
                 <a:ea typeface="Helvetica Neue" pitchFamily="34" charset="-122"/>
@@ -6921,7 +6921,7 @@
             <a:r>
               <a:rPr lang="en-US" sz="1000" b="1" spc="300" kern="0" dirty="0">
                 <a:solidFill>
-                  <a:srgbClr val="8A8A8A"/>
+                  <a:srgbClr val="9A8889"/>
                 </a:solidFill>
                 <a:latin typeface="Helvetica Neue" pitchFamily="34" charset="0"/>
                 <a:ea typeface="Helvetica Neue" pitchFamily="34" charset="-122"/>
@@ -6960,7 +6960,7 @@
             <a:r>
               <a:rPr lang="en-US" sz="1050" dirty="0">
                 <a:solidFill>
-                  <a:srgbClr val="404040"/>
+                  <a:srgbClr val="3A2628"/>
                 </a:solidFill>
                 <a:latin typeface="Helvetica Neue" pitchFamily="34" charset="0"/>
                 <a:ea typeface="Helvetica Neue" pitchFamily="34" charset="-122"/>
@@ -6987,11 +6987,11 @@
             <a:avLst/>
           </a:prstGeom>
           <a:solidFill>
-            <a:srgbClr val="F7F7F5"/>
+            <a:srgbClr val="FBF4F5"/>
           </a:solidFill>
           <a:ln w="12700">
             <a:solidFill>
-              <a:srgbClr val="D8D8D5"/>
+              <a:srgbClr val="ECD9DB"/>
             </a:solidFill>
             <a:prstDash val="solid"/>
           </a:ln>
@@ -7012,11 +7012,11 @@
             <a:avLst/>
           </a:prstGeom>
           <a:solidFill>
-            <a:srgbClr val="1A1A1A"/>
+            <a:srgbClr val="B91C1C"/>
           </a:solidFill>
           <a:ln w="12700">
             <a:solidFill>
-              <a:srgbClr val="1A1A1A"/>
+              <a:srgbClr val="1F1213"/>
             </a:solidFill>
             <a:prstDash val="solid"/>
           </a:ln>
@@ -7049,7 +7049,7 @@
             <a:r>
               <a:rPr lang="en-US" sz="1500" b="1" dirty="0">
                 <a:solidFill>
-                  <a:srgbClr val="1A1A1A"/>
+                  <a:srgbClr val="1F1213"/>
                 </a:solidFill>
                 <a:latin typeface="Helvetica Neue" pitchFamily="34" charset="0"/>
                 <a:ea typeface="Helvetica Neue" pitchFamily="34" charset="-122"/>
@@ -7088,7 +7088,7 @@
             <a:r>
               <a:rPr lang="en-US" sz="1000" b="1" spc="300" kern="0" dirty="0">
                 <a:solidFill>
-                  <a:srgbClr val="8A8A8A"/>
+                  <a:srgbClr val="9A8889"/>
                 </a:solidFill>
                 <a:latin typeface="Helvetica Neue" pitchFamily="34" charset="0"/>
                 <a:ea typeface="Helvetica Neue" pitchFamily="34" charset="-122"/>
@@ -7127,7 +7127,7 @@
             <a:r>
               <a:rPr lang="en-US" sz="1050" dirty="0">
                 <a:solidFill>
-                  <a:srgbClr val="404040"/>
+                  <a:srgbClr val="3A2628"/>
                 </a:solidFill>
                 <a:latin typeface="Helvetica Neue" pitchFamily="34" charset="0"/>
                 <a:ea typeface="Helvetica Neue" pitchFamily="34" charset="-122"/>
@@ -7166,7 +7166,7 @@
             <a:r>
               <a:rPr lang="en-US" sz="1100" b="1" spc="400" kern="0" dirty="0">
                 <a:solidFill>
-                  <a:srgbClr val="8A8A8A"/>
+                  <a:srgbClr val="9A8889"/>
                 </a:solidFill>
                 <a:latin typeface="Helvetica Neue" pitchFamily="34" charset="0"/>
                 <a:ea typeface="Helvetica Neue" pitchFamily="34" charset="-122"/>
@@ -7205,7 +7205,7 @@
             <a:r>
               <a:rPr lang="en-US" sz="1000" i="1" dirty="0">
                 <a:solidFill>
-                  <a:srgbClr val="8A8A8A"/>
+                  <a:srgbClr val="9A8889"/>
                 </a:solidFill>
                 <a:latin typeface="Helvetica Neue" pitchFamily="34" charset="0"/>
                 <a:ea typeface="Helvetica Neue" pitchFamily="34" charset="-122"/>
@@ -7234,7 +7234,7 @@
           <a:noFill/>
           <a:ln w="25400">
             <a:solidFill>
-              <a:srgbClr val="D8D8D5"/>
+              <a:srgbClr val="ECD9DB"/>
             </a:solidFill>
             <a:prstDash val="solid"/>
           </a:ln>
@@ -7255,11 +7255,11 @@
             <a:avLst/>
           </a:prstGeom>
           <a:solidFill>
-            <a:srgbClr val="1A1A1A"/>
+            <a:srgbClr val="B91C1C"/>
           </a:solidFill>
           <a:ln w="12700">
             <a:solidFill>
-              <a:srgbClr val="1A1A1A"/>
+              <a:srgbClr val="1F1213"/>
             </a:solidFill>
             <a:prstDash val="solid"/>
           </a:ln>
@@ -7292,7 +7292,7 @@
             <a:r>
               <a:rPr lang="en-US" sz="2800" b="1" dirty="0">
                 <a:solidFill>
-                  <a:srgbClr val="1A1A1A"/>
+                  <a:srgbClr val="1F1213"/>
                 </a:solidFill>
                 <a:latin typeface="Helvetica Neue" pitchFamily="34" charset="0"/>
                 <a:ea typeface="Helvetica Neue" pitchFamily="34" charset="-122"/>
@@ -7331,7 +7331,7 @@
             <a:r>
               <a:rPr lang="en-US" sz="1200" b="1" dirty="0">
                 <a:solidFill>
-                  <a:srgbClr val="1A1A1A"/>
+                  <a:srgbClr val="1F1213"/>
                 </a:solidFill>
                 <a:latin typeface="Helvetica Neue" pitchFamily="34" charset="0"/>
                 <a:ea typeface="Helvetica Neue" pitchFamily="34" charset="-122"/>
@@ -7370,7 +7370,7 @@
             <a:r>
               <a:rPr lang="en-US" sz="1000" i="1" dirty="0">
                 <a:solidFill>
-                  <a:srgbClr val="5A5A5A"/>
+                  <a:srgbClr val="6B5557"/>
                 </a:solidFill>
                 <a:latin typeface="Helvetica Neue" pitchFamily="34" charset="0"/>
                 <a:ea typeface="Helvetica Neue" pitchFamily="34" charset="-122"/>
@@ -7397,11 +7397,11 @@
             <a:avLst/>
           </a:prstGeom>
           <a:solidFill>
-            <a:srgbClr val="1A1A1A"/>
+            <a:srgbClr val="B91C1C"/>
           </a:solidFill>
           <a:ln w="12700">
             <a:solidFill>
-              <a:srgbClr val="1A1A1A"/>
+              <a:srgbClr val="1F1213"/>
             </a:solidFill>
             <a:prstDash val="solid"/>
           </a:ln>
@@ -7434,7 +7434,7 @@
             <a:r>
               <a:rPr lang="en-US" sz="2800" b="1" dirty="0">
                 <a:solidFill>
-                  <a:srgbClr val="1A1A1A"/>
+                  <a:srgbClr val="1F1213"/>
                 </a:solidFill>
                 <a:latin typeface="Helvetica Neue" pitchFamily="34" charset="0"/>
                 <a:ea typeface="Helvetica Neue" pitchFamily="34" charset="-122"/>
@@ -7473,7 +7473,7 @@
             <a:r>
               <a:rPr lang="en-US" sz="1200" b="1" dirty="0">
                 <a:solidFill>
-                  <a:srgbClr val="1A1A1A"/>
+                  <a:srgbClr val="1F1213"/>
                 </a:solidFill>
                 <a:latin typeface="Helvetica Neue" pitchFamily="34" charset="0"/>
                 <a:ea typeface="Helvetica Neue" pitchFamily="34" charset="-122"/>
@@ -7512,7 +7512,7 @@
             <a:r>
               <a:rPr lang="en-US" sz="1000" i="1" dirty="0">
                 <a:solidFill>
-                  <a:srgbClr val="5A5A5A"/>
+                  <a:srgbClr val="6B5557"/>
                 </a:solidFill>
                 <a:latin typeface="Helvetica Neue" pitchFamily="34" charset="0"/>
                 <a:ea typeface="Helvetica Neue" pitchFamily="34" charset="-122"/>
@@ -7539,11 +7539,11 @@
             <a:avLst/>
           </a:prstGeom>
           <a:solidFill>
-            <a:srgbClr val="1A1A1A"/>
+            <a:srgbClr val="B91C1C"/>
           </a:solidFill>
           <a:ln w="12700">
             <a:solidFill>
-              <a:srgbClr val="1A1A1A"/>
+              <a:srgbClr val="1F1213"/>
             </a:solidFill>
             <a:prstDash val="solid"/>
           </a:ln>
@@ -7576,7 +7576,7 @@
             <a:r>
               <a:rPr lang="en-US" sz="2800" b="1" dirty="0">
                 <a:solidFill>
-                  <a:srgbClr val="1A1A1A"/>
+                  <a:srgbClr val="1F1213"/>
                 </a:solidFill>
                 <a:latin typeface="Helvetica Neue" pitchFamily="34" charset="0"/>
                 <a:ea typeface="Helvetica Neue" pitchFamily="34" charset="-122"/>
@@ -7615,7 +7615,7 @@
             <a:r>
               <a:rPr lang="en-US" sz="1200" b="1" dirty="0">
                 <a:solidFill>
-                  <a:srgbClr val="1A1A1A"/>
+                  <a:srgbClr val="1F1213"/>
                 </a:solidFill>
                 <a:latin typeface="Helvetica Neue" pitchFamily="34" charset="0"/>
                 <a:ea typeface="Helvetica Neue" pitchFamily="34" charset="-122"/>
@@ -7654,7 +7654,7 @@
             <a:r>
               <a:rPr lang="en-US" sz="1000" i="1" dirty="0">
                 <a:solidFill>
-                  <a:srgbClr val="5A5A5A"/>
+                  <a:srgbClr val="6B5557"/>
                 </a:solidFill>
                 <a:latin typeface="Helvetica Neue" pitchFamily="34" charset="0"/>
                 <a:ea typeface="Helvetica Neue" pitchFamily="34" charset="-122"/>
@@ -7693,7 +7693,7 @@
             <a:r>
               <a:rPr lang="en-US" sz="900" dirty="0">
                 <a:solidFill>
-                  <a:srgbClr val="8A8A8A"/>
+                  <a:srgbClr val="9A8889"/>
                 </a:solidFill>
                 <a:latin typeface="Helvetica Neue" pitchFamily="34" charset="0"/>
                 <a:ea typeface="Helvetica Neue" pitchFamily="34" charset="-122"/>
@@ -7764,7 +7764,7 @@
             <a:r>
               <a:rPr lang="en-US" sz="8000" b="1" dirty="0">
                 <a:solidFill>
-                  <a:srgbClr val="1A1A1A"/>
+                  <a:srgbClr val="1F1213"/>
                 </a:solidFill>
                 <a:latin typeface="Helvetica Neue" pitchFamily="34" charset="0"/>
                 <a:ea typeface="Helvetica Neue" pitchFamily="34" charset="-122"/>
@@ -7793,7 +7793,7 @@
           <a:noFill/>
           <a:ln w="19050">
             <a:solidFill>
-              <a:srgbClr val="1A1A1A"/>
+              <a:srgbClr val="B91C1C"/>
             </a:solidFill>
             <a:prstDash val="solid"/>
           </a:ln>
@@ -7826,7 +7826,7 @@
             <a:r>
               <a:rPr lang="en-US" sz="1400" dirty="0">
                 <a:solidFill>
-                  <a:srgbClr val="5A5A5A"/>
+                  <a:srgbClr val="6B5557"/>
                 </a:solidFill>
                 <a:latin typeface="Helvetica Neue" pitchFamily="34" charset="0"/>
                 <a:ea typeface="Helvetica Neue" pitchFamily="34" charset="-122"/>
@@ -7865,7 +7865,7 @@
             <a:r>
               <a:rPr lang="en-US" sz="1100" spc="300" kern="0" dirty="0">
                 <a:solidFill>
-                  <a:srgbClr val="8A8A8A"/>
+                  <a:srgbClr val="9A8889"/>
                 </a:solidFill>
                 <a:latin typeface="Helvetica Neue" pitchFamily="34" charset="0"/>
                 <a:ea typeface="Helvetica Neue" pitchFamily="34" charset="-122"/>
@@ -7936,7 +7936,7 @@
             <a:r>
               <a:rPr lang="en-US" sz="900" spc="400" kern="0" dirty="0">
                 <a:solidFill>
-                  <a:srgbClr val="8A8A8A"/>
+                  <a:srgbClr val="9A8889"/>
                 </a:solidFill>
                 <a:latin typeface="Helvetica Neue" pitchFamily="34" charset="0"/>
                 <a:ea typeface="Helvetica Neue" pitchFamily="34" charset="-122"/>
@@ -7975,7 +7975,7 @@
             <a:r>
               <a:rPr lang="en-US" sz="3600" b="1" dirty="0">
                 <a:solidFill>
-                  <a:srgbClr val="1A1A1A"/>
+                  <a:srgbClr val="1F1213"/>
                 </a:solidFill>
                 <a:latin typeface="Helvetica Neue" pitchFamily="34" charset="0"/>
                 <a:ea typeface="Helvetica Neue" pitchFamily="34" charset="-122"/>
@@ -8004,7 +8004,7 @@
           <a:noFill/>
           <a:ln w="19050">
             <a:solidFill>
-              <a:srgbClr val="1A1A1A"/>
+              <a:srgbClr val="B91C1C"/>
             </a:solidFill>
             <a:prstDash val="solid"/>
           </a:ln>
@@ -8025,11 +8025,11 @@
             <a:avLst/>
           </a:prstGeom>
           <a:solidFill>
-            <a:srgbClr val="1A1A1A"/>
+            <a:srgbClr val="B91C1C"/>
           </a:solidFill>
           <a:ln w="12700">
             <a:solidFill>
-              <a:srgbClr val="1A1A1A"/>
+              <a:srgbClr val="1F1213"/>
             </a:solidFill>
             <a:prstDash val="solid"/>
           </a:ln>
@@ -8062,7 +8062,7 @@
             <a:r>
               <a:rPr lang="en-US" sz="2200" dirty="0">
                 <a:solidFill>
-                  <a:srgbClr val="404040"/>
+                  <a:srgbClr val="3A2628"/>
                 </a:solidFill>
                 <a:latin typeface="Helvetica Neue" pitchFamily="34" charset="0"/>
                 <a:ea typeface="Helvetica Neue" pitchFamily="34" charset="-122"/>
@@ -8089,11 +8089,11 @@
             <a:avLst/>
           </a:prstGeom>
           <a:solidFill>
-            <a:srgbClr val="1A1A1A"/>
+            <a:srgbClr val="B91C1C"/>
           </a:solidFill>
           <a:ln w="12700">
             <a:solidFill>
-              <a:srgbClr val="1A1A1A"/>
+              <a:srgbClr val="1F1213"/>
             </a:solidFill>
             <a:prstDash val="solid"/>
           </a:ln>
@@ -8126,7 +8126,7 @@
             <a:r>
               <a:rPr lang="en-US" sz="2200" dirty="0">
                 <a:solidFill>
-                  <a:srgbClr val="404040"/>
+                  <a:srgbClr val="3A2628"/>
                 </a:solidFill>
                 <a:latin typeface="Helvetica Neue" pitchFamily="34" charset="0"/>
                 <a:ea typeface="Helvetica Neue" pitchFamily="34" charset="-122"/>
@@ -8153,11 +8153,11 @@
             <a:avLst/>
           </a:prstGeom>
           <a:solidFill>
-            <a:srgbClr val="1A1A1A"/>
+            <a:srgbClr val="B91C1C"/>
           </a:solidFill>
           <a:ln w="12700">
             <a:solidFill>
-              <a:srgbClr val="1A1A1A"/>
+              <a:srgbClr val="1F1213"/>
             </a:solidFill>
             <a:prstDash val="solid"/>
           </a:ln>
@@ -8190,7 +8190,7 @@
             <a:r>
               <a:rPr lang="en-US" sz="2200" dirty="0">
                 <a:solidFill>
-                  <a:srgbClr val="404040"/>
+                  <a:srgbClr val="3A2628"/>
                 </a:solidFill>
                 <a:latin typeface="Helvetica Neue" pitchFamily="34" charset="0"/>
                 <a:ea typeface="Helvetica Neue" pitchFamily="34" charset="-122"/>
@@ -8217,11 +8217,11 @@
             <a:avLst/>
           </a:prstGeom>
           <a:solidFill>
-            <a:srgbClr val="1A1A1A"/>
+            <a:srgbClr val="B91C1C"/>
           </a:solidFill>
           <a:ln w="12700">
             <a:solidFill>
-              <a:srgbClr val="1A1A1A"/>
+              <a:srgbClr val="1F1213"/>
             </a:solidFill>
             <a:prstDash val="solid"/>
           </a:ln>
@@ -8254,7 +8254,7 @@
             <a:r>
               <a:rPr lang="en-US" sz="2200" dirty="0">
                 <a:solidFill>
-                  <a:srgbClr val="404040"/>
+                  <a:srgbClr val="3A2628"/>
                 </a:solidFill>
                 <a:latin typeface="Helvetica Neue" pitchFamily="34" charset="0"/>
                 <a:ea typeface="Helvetica Neue" pitchFamily="34" charset="-122"/>
@@ -8293,7 +8293,7 @@
             <a:r>
               <a:rPr lang="en-US" sz="1800" i="1" dirty="0">
                 <a:solidFill>
-                  <a:srgbClr val="1A1A1A"/>
+                  <a:srgbClr val="1F1213"/>
                 </a:solidFill>
                 <a:latin typeface="Helvetica Neue" pitchFamily="34" charset="0"/>
                 <a:ea typeface="Helvetica Neue" pitchFamily="34" charset="-122"/>
@@ -8332,7 +8332,7 @@
             <a:r>
               <a:rPr lang="en-US" sz="900" dirty="0">
                 <a:solidFill>
-                  <a:srgbClr val="8A8A8A"/>
+                  <a:srgbClr val="9A8889"/>
                 </a:solidFill>
                 <a:latin typeface="Helvetica Neue" pitchFamily="34" charset="0"/>
                 <a:ea typeface="Helvetica Neue" pitchFamily="34" charset="-122"/>
@@ -8358,7 +8358,7 @@
     <p:bg>
       <p:bgPr>
         <a:solidFill>
-          <a:srgbClr val="1A1A1A"/>
+          <a:srgbClr val="7F1D1D"/>
         </a:solidFill>
       </p:bgPr>
     </p:bg>
@@ -8403,7 +8403,7 @@
             <a:r>
               <a:rPr lang="en-US" sz="1100" b="1" spc="800" kern="0" dirty="0">
                 <a:solidFill>
-                  <a:srgbClr val="8A8A8A"/>
+                  <a:srgbClr val="9A8889"/>
                 </a:solidFill>
                 <a:latin typeface="Helvetica Neue" pitchFamily="34" charset="0"/>
                 <a:ea typeface="Helvetica Neue" pitchFamily="34" charset="-122"/>
@@ -8520,7 +8520,7 @@
             <a:r>
               <a:rPr lang="en-US" sz="1100" b="1" spc="400" kern="0" dirty="0">
                 <a:solidFill>
-                  <a:srgbClr val="8A8A8A"/>
+                  <a:srgbClr val="9A8889"/>
                 </a:solidFill>
                 <a:latin typeface="Helvetica Neue" pitchFamily="34" charset="0"/>
                 <a:ea typeface="Helvetica Neue" pitchFamily="34" charset="-122"/>
@@ -8591,7 +8591,7 @@
             <a:r>
               <a:rPr lang="en-US" sz="900" spc="400" kern="0" dirty="0">
                 <a:solidFill>
-                  <a:srgbClr val="8A8A8A"/>
+                  <a:srgbClr val="9A8889"/>
                 </a:solidFill>
                 <a:latin typeface="Helvetica Neue" pitchFamily="34" charset="0"/>
                 <a:ea typeface="Helvetica Neue" pitchFamily="34" charset="-122"/>
@@ -8630,7 +8630,7 @@
             <a:r>
               <a:rPr lang="en-US" sz="3600" b="1" dirty="0">
                 <a:solidFill>
-                  <a:srgbClr val="1A1A1A"/>
+                  <a:srgbClr val="1F1213"/>
                 </a:solidFill>
                 <a:latin typeface="Helvetica Neue" pitchFamily="34" charset="0"/>
                 <a:ea typeface="Helvetica Neue" pitchFamily="34" charset="-122"/>
@@ -8659,7 +8659,7 @@
           <a:noFill/>
           <a:ln w="19050">
             <a:solidFill>
-              <a:srgbClr val="1A1A1A"/>
+              <a:srgbClr val="B91C1C"/>
             </a:solidFill>
             <a:prstDash val="solid"/>
           </a:ln>
@@ -8680,11 +8680,11 @@
             <a:avLst/>
           </a:prstGeom>
           <a:solidFill>
-            <a:srgbClr val="F7F7F5"/>
+            <a:srgbClr val="FBF4F5"/>
           </a:solidFill>
           <a:ln w="12700">
             <a:solidFill>
-              <a:srgbClr val="D8D8D5"/>
+              <a:srgbClr val="ECD9DB"/>
             </a:solidFill>
             <a:prstDash val="solid"/>
           </a:ln>
@@ -8717,7 +8717,7 @@
             <a:r>
               <a:rPr lang="en-US" sz="1300" b="1" dirty="0">
                 <a:solidFill>
-                  <a:srgbClr val="1A1A1A"/>
+                  <a:srgbClr val="1F1213"/>
                 </a:solidFill>
                 <a:latin typeface="Helvetica Neue" pitchFamily="34" charset="0"/>
                 <a:ea typeface="Helvetica Neue" pitchFamily="34" charset="-122"/>
@@ -8756,7 +8756,7 @@
             <a:r>
               <a:rPr lang="en-US" sz="1000" dirty="0">
                 <a:solidFill>
-                  <a:srgbClr val="5A5A5A"/>
+                  <a:srgbClr val="6B5557"/>
                 </a:solidFill>
                 <a:latin typeface="Helvetica Neue" pitchFamily="34" charset="0"/>
                 <a:ea typeface="Helvetica Neue" pitchFamily="34" charset="-122"/>
@@ -8785,7 +8785,7 @@
           <a:noFill/>
           <a:ln w="12700">
             <a:solidFill>
-              <a:srgbClr val="5A5A5A"/>
+              <a:srgbClr val="6B5557"/>
             </a:solidFill>
             <a:prstDash val="solid"/>
           </a:ln>
@@ -8806,11 +8806,11 @@
             <a:avLst/>
           </a:prstGeom>
           <a:solidFill>
-            <a:srgbClr val="F7F7F5"/>
+            <a:srgbClr val="FBF4F5"/>
           </a:solidFill>
           <a:ln w="12700">
             <a:solidFill>
-              <a:srgbClr val="D8D8D5"/>
+              <a:srgbClr val="ECD9DB"/>
             </a:solidFill>
             <a:prstDash val="solid"/>
           </a:ln>
@@ -8843,7 +8843,7 @@
             <a:r>
               <a:rPr lang="en-US" sz="1300" b="1" dirty="0">
                 <a:solidFill>
-                  <a:srgbClr val="1A1A1A"/>
+                  <a:srgbClr val="1F1213"/>
                 </a:solidFill>
                 <a:latin typeface="Helvetica Neue" pitchFamily="34" charset="0"/>
                 <a:ea typeface="Helvetica Neue" pitchFamily="34" charset="-122"/>
@@ -8882,7 +8882,7 @@
             <a:r>
               <a:rPr lang="en-US" sz="1000" dirty="0">
                 <a:solidFill>
-                  <a:srgbClr val="5A5A5A"/>
+                  <a:srgbClr val="6B5557"/>
                 </a:solidFill>
                 <a:latin typeface="Helvetica Neue" pitchFamily="34" charset="0"/>
                 <a:ea typeface="Helvetica Neue" pitchFamily="34" charset="-122"/>
@@ -8911,7 +8911,7 @@
           <a:noFill/>
           <a:ln w="12700">
             <a:solidFill>
-              <a:srgbClr val="5A5A5A"/>
+              <a:srgbClr val="6B5557"/>
             </a:solidFill>
             <a:prstDash val="solid"/>
           </a:ln>
@@ -8932,11 +8932,11 @@
             <a:avLst/>
           </a:prstGeom>
           <a:solidFill>
-            <a:srgbClr val="F7F7F5"/>
+            <a:srgbClr val="FBF4F5"/>
           </a:solidFill>
           <a:ln w="12700">
             <a:solidFill>
-              <a:srgbClr val="D8D8D5"/>
+              <a:srgbClr val="ECD9DB"/>
             </a:solidFill>
             <a:prstDash val="solid"/>
           </a:ln>
@@ -8969,7 +8969,7 @@
             <a:r>
               <a:rPr lang="en-US" sz="1300" b="1" dirty="0">
                 <a:solidFill>
-                  <a:srgbClr val="1A1A1A"/>
+                  <a:srgbClr val="1F1213"/>
                 </a:solidFill>
                 <a:latin typeface="Helvetica Neue" pitchFamily="34" charset="0"/>
                 <a:ea typeface="Helvetica Neue" pitchFamily="34" charset="-122"/>
@@ -9008,7 +9008,7 @@
             <a:r>
               <a:rPr lang="en-US" sz="1000" dirty="0">
                 <a:solidFill>
-                  <a:srgbClr val="5A5A5A"/>
+                  <a:srgbClr val="6B5557"/>
                 </a:solidFill>
                 <a:latin typeface="Helvetica Neue" pitchFamily="34" charset="0"/>
                 <a:ea typeface="Helvetica Neue" pitchFamily="34" charset="-122"/>
@@ -9037,7 +9037,7 @@
           <a:noFill/>
           <a:ln w="12700">
             <a:solidFill>
-              <a:srgbClr val="5A5A5A"/>
+              <a:srgbClr val="6B5557"/>
             </a:solidFill>
             <a:prstDash val="solid"/>
           </a:ln>
@@ -9058,11 +9058,11 @@
             <a:avLst/>
           </a:prstGeom>
           <a:solidFill>
-            <a:srgbClr val="1A1A1A"/>
+            <a:srgbClr val="7F1D1D"/>
           </a:solidFill>
           <a:ln w="12700">
             <a:solidFill>
-              <a:srgbClr val="1A1A1A"/>
+              <a:srgbClr val="1F1213"/>
             </a:solidFill>
             <a:prstDash val="solid"/>
           </a:ln>
@@ -9163,7 +9163,7 @@
           <a:noFill/>
           <a:ln w="12700">
             <a:solidFill>
-              <a:srgbClr val="5A5A5A"/>
+              <a:srgbClr val="6B5557"/>
             </a:solidFill>
             <a:prstDash val="solid"/>
           </a:ln>
@@ -9184,11 +9184,11 @@
             <a:avLst/>
           </a:prstGeom>
           <a:solidFill>
-            <a:srgbClr val="F7F7F5"/>
+            <a:srgbClr val="FBF4F5"/>
           </a:solidFill>
           <a:ln w="12700">
             <a:solidFill>
-              <a:srgbClr val="D8D8D5"/>
+              <a:srgbClr val="ECD9DB"/>
             </a:solidFill>
             <a:prstDash val="solid"/>
           </a:ln>
@@ -9221,7 +9221,7 @@
             <a:r>
               <a:rPr lang="en-US" sz="1300" b="1" dirty="0">
                 <a:solidFill>
-                  <a:srgbClr val="1A1A1A"/>
+                  <a:srgbClr val="1F1213"/>
                 </a:solidFill>
                 <a:latin typeface="Helvetica Neue" pitchFamily="34" charset="0"/>
                 <a:ea typeface="Helvetica Neue" pitchFamily="34" charset="-122"/>
@@ -9260,7 +9260,7 @@
             <a:r>
               <a:rPr lang="en-US" sz="1000" dirty="0">
                 <a:solidFill>
-                  <a:srgbClr val="5A5A5A"/>
+                  <a:srgbClr val="6B5557"/>
                 </a:solidFill>
                 <a:latin typeface="Helvetica Neue" pitchFamily="34" charset="0"/>
                 <a:ea typeface="Helvetica Neue" pitchFamily="34" charset="-122"/>
@@ -9287,11 +9287,11 @@
             <a:avLst/>
           </a:prstGeom>
           <a:solidFill>
-            <a:srgbClr val="F7F7F5"/>
+            <a:srgbClr val="FBF4F5"/>
           </a:solidFill>
           <a:ln w="12700">
             <a:solidFill>
-              <a:srgbClr val="D8D8D5"/>
+              <a:srgbClr val="ECD9DB"/>
             </a:solidFill>
             <a:prstDash val="solid"/>
           </a:ln>
@@ -9324,7 +9324,7 @@
             <a:r>
               <a:rPr lang="en-US" sz="1300" b="1" dirty="0">
                 <a:solidFill>
-                  <a:srgbClr val="1A1A1A"/>
+                  <a:srgbClr val="1F1213"/>
                 </a:solidFill>
                 <a:latin typeface="Helvetica Neue" pitchFamily="34" charset="0"/>
                 <a:ea typeface="Helvetica Neue" pitchFamily="34" charset="-122"/>
@@ -9363,7 +9363,7 @@
             <a:r>
               <a:rPr lang="en-US" sz="1000" dirty="0">
                 <a:solidFill>
-                  <a:srgbClr val="5A5A5A"/>
+                  <a:srgbClr val="6B5557"/>
                 </a:solidFill>
                 <a:latin typeface="Helvetica Neue" pitchFamily="34" charset="0"/>
                 <a:ea typeface="Helvetica Neue" pitchFamily="34" charset="-122"/>
@@ -9390,11 +9390,11 @@
             <a:avLst/>
           </a:prstGeom>
           <a:solidFill>
-            <a:srgbClr val="F7F7F5"/>
+            <a:srgbClr val="FBF4F5"/>
           </a:solidFill>
           <a:ln w="12700">
             <a:solidFill>
-              <a:srgbClr val="D8D8D5"/>
+              <a:srgbClr val="ECD9DB"/>
             </a:solidFill>
             <a:prstDash val="solid"/>
           </a:ln>
@@ -9427,7 +9427,7 @@
             <a:r>
               <a:rPr lang="en-US" sz="1300" b="1" dirty="0">
                 <a:solidFill>
-                  <a:srgbClr val="1A1A1A"/>
+                  <a:srgbClr val="1F1213"/>
                 </a:solidFill>
                 <a:latin typeface="Helvetica Neue" pitchFamily="34" charset="0"/>
                 <a:ea typeface="Helvetica Neue" pitchFamily="34" charset="-122"/>
@@ -9466,7 +9466,7 @@
             <a:r>
               <a:rPr lang="en-US" sz="1000" dirty="0">
                 <a:solidFill>
-                  <a:srgbClr val="5A5A5A"/>
+                  <a:srgbClr val="6B5557"/>
                 </a:solidFill>
                 <a:latin typeface="Helvetica Neue" pitchFamily="34" charset="0"/>
                 <a:ea typeface="Helvetica Neue" pitchFamily="34" charset="-122"/>
@@ -9493,11 +9493,11 @@
             <a:avLst/>
           </a:prstGeom>
           <a:solidFill>
-            <a:srgbClr val="F7F7F5"/>
+            <a:srgbClr val="FBF4F5"/>
           </a:solidFill>
           <a:ln w="12700">
             <a:solidFill>
-              <a:srgbClr val="D8D8D5"/>
+              <a:srgbClr val="ECD9DB"/>
             </a:solidFill>
             <a:prstDash val="solid"/>
           </a:ln>
@@ -9530,7 +9530,7 @@
             <a:r>
               <a:rPr lang="en-US" sz="1300" b="1" dirty="0">
                 <a:solidFill>
-                  <a:srgbClr val="1A1A1A"/>
+                  <a:srgbClr val="1F1213"/>
                 </a:solidFill>
                 <a:latin typeface="Helvetica Neue" pitchFamily="34" charset="0"/>
                 <a:ea typeface="Helvetica Neue" pitchFamily="34" charset="-122"/>
@@ -9569,7 +9569,7 @@
             <a:r>
               <a:rPr lang="en-US" sz="1000" dirty="0">
                 <a:solidFill>
-                  <a:srgbClr val="5A5A5A"/>
+                  <a:srgbClr val="6B5557"/>
                 </a:solidFill>
                 <a:latin typeface="Helvetica Neue" pitchFamily="34" charset="0"/>
                 <a:ea typeface="Helvetica Neue" pitchFamily="34" charset="-122"/>
@@ -9608,7 +9608,7 @@
             <a:r>
               <a:rPr lang="en-US" sz="900" dirty="0">
                 <a:solidFill>
-                  <a:srgbClr val="8A8A8A"/>
+                  <a:srgbClr val="9A8889"/>
                 </a:solidFill>
                 <a:latin typeface="Helvetica Neue" pitchFamily="34" charset="0"/>
                 <a:ea typeface="Helvetica Neue" pitchFamily="34" charset="-122"/>
@@ -9679,7 +9679,7 @@
             <a:r>
               <a:rPr lang="en-US" sz="900" spc="400" kern="0" dirty="0">
                 <a:solidFill>
-                  <a:srgbClr val="8A8A8A"/>
+                  <a:srgbClr val="9A8889"/>
                 </a:solidFill>
                 <a:latin typeface="Helvetica Neue" pitchFamily="34" charset="0"/>
                 <a:ea typeface="Helvetica Neue" pitchFamily="34" charset="-122"/>
@@ -9718,7 +9718,7 @@
             <a:r>
               <a:rPr lang="en-US" sz="3600" b="1" dirty="0">
                 <a:solidFill>
-                  <a:srgbClr val="1A1A1A"/>
+                  <a:srgbClr val="1F1213"/>
                 </a:solidFill>
                 <a:latin typeface="Helvetica Neue" pitchFamily="34" charset="0"/>
                 <a:ea typeface="Helvetica Neue" pitchFamily="34" charset="-122"/>
@@ -9747,7 +9747,7 @@
           <a:noFill/>
           <a:ln w="19050">
             <a:solidFill>
-              <a:srgbClr val="1A1A1A"/>
+              <a:srgbClr val="B91C1C"/>
             </a:solidFill>
             <a:prstDash val="solid"/>
           </a:ln>
@@ -9780,7 +9780,7 @@
             <a:r>
               <a:rPr lang="en-US" sz="1500" i="1" dirty="0">
                 <a:solidFill>
-                  <a:srgbClr val="5A5A5A"/>
+                  <a:srgbClr val="6B5557"/>
                 </a:solidFill>
                 <a:latin typeface="Helvetica Neue" pitchFamily="34" charset="0"/>
                 <a:ea typeface="Helvetica Neue" pitchFamily="34" charset="-122"/>
@@ -9807,11 +9807,11 @@
             <a:avLst/>
           </a:prstGeom>
           <a:solidFill>
-            <a:srgbClr val="F7F7F5"/>
+            <a:srgbClr val="FBF4F5"/>
           </a:solidFill>
           <a:ln w="12700">
             <a:solidFill>
-              <a:srgbClr val="D8D8D5"/>
+              <a:srgbClr val="ECD9DB"/>
             </a:solidFill>
             <a:prstDash val="solid"/>
           </a:ln>
@@ -9832,11 +9832,11 @@
             <a:avLst/>
           </a:prstGeom>
           <a:solidFill>
-            <a:srgbClr val="1A1A1A"/>
+            <a:srgbClr val="B91C1C"/>
           </a:solidFill>
           <a:ln w="12700">
             <a:solidFill>
-              <a:srgbClr val="1A1A1A"/>
+              <a:srgbClr val="1F1213"/>
             </a:solidFill>
             <a:prstDash val="solid"/>
           </a:ln>
@@ -9869,7 +9869,7 @@
             <a:r>
               <a:rPr lang="en-US" sz="1300" b="1" dirty="0">
                 <a:solidFill>
-                  <a:srgbClr val="1A1A1A"/>
+                  <a:srgbClr val="1F1213"/>
                 </a:solidFill>
                 <a:latin typeface="Helvetica Neue" pitchFamily="34" charset="0"/>
                 <a:ea typeface="Helvetica Neue" pitchFamily="34" charset="-122"/>
@@ -9908,7 +9908,7 @@
             <a:r>
               <a:rPr lang="en-US" sz="1100" dirty="0">
                 <a:solidFill>
-                  <a:srgbClr val="5A5A5A"/>
+                  <a:srgbClr val="6B5557"/>
                 </a:solidFill>
                 <a:latin typeface="Helvetica Neue" pitchFamily="34" charset="0"/>
                 <a:ea typeface="Helvetica Neue" pitchFamily="34" charset="-122"/>
@@ -9947,7 +9947,7 @@
             <a:r>
               <a:rPr lang="en-US" sz="1100" dirty="0">
                 <a:solidFill>
-                  <a:srgbClr val="404040"/>
+                  <a:srgbClr val="3A2628"/>
                 </a:solidFill>
                 <a:latin typeface="Helvetica Neue" pitchFamily="34" charset="0"/>
                 <a:ea typeface="Helvetica Neue" pitchFamily="34" charset="-122"/>
@@ -9974,11 +9974,11 @@
             <a:avLst/>
           </a:prstGeom>
           <a:solidFill>
-            <a:srgbClr val="F7F7F5"/>
+            <a:srgbClr val="FBF4F5"/>
           </a:solidFill>
           <a:ln w="12700">
             <a:solidFill>
-              <a:srgbClr val="D8D8D5"/>
+              <a:srgbClr val="ECD9DB"/>
             </a:solidFill>
             <a:prstDash val="solid"/>
           </a:ln>
@@ -9999,11 +9999,11 @@
             <a:avLst/>
           </a:prstGeom>
           <a:solidFill>
-            <a:srgbClr val="1A1A1A"/>
+            <a:srgbClr val="B91C1C"/>
           </a:solidFill>
           <a:ln w="12700">
             <a:solidFill>
-              <a:srgbClr val="1A1A1A"/>
+              <a:srgbClr val="1F1213"/>
             </a:solidFill>
             <a:prstDash val="solid"/>
           </a:ln>
@@ -10036,7 +10036,7 @@
             <a:r>
               <a:rPr lang="en-US" sz="1300" b="1" dirty="0">
                 <a:solidFill>
-                  <a:srgbClr val="1A1A1A"/>
+                  <a:srgbClr val="1F1213"/>
                 </a:solidFill>
                 <a:latin typeface="Helvetica Neue" pitchFamily="34" charset="0"/>
                 <a:ea typeface="Helvetica Neue" pitchFamily="34" charset="-122"/>
@@ -10075,7 +10075,7 @@
             <a:r>
               <a:rPr lang="en-US" sz="1100" dirty="0">
                 <a:solidFill>
-                  <a:srgbClr val="5A5A5A"/>
+                  <a:srgbClr val="6B5557"/>
                 </a:solidFill>
                 <a:latin typeface="Helvetica Neue" pitchFamily="34" charset="0"/>
                 <a:ea typeface="Helvetica Neue" pitchFamily="34" charset="-122"/>
@@ -10114,7 +10114,7 @@
             <a:r>
               <a:rPr lang="en-US" sz="1100" dirty="0">
                 <a:solidFill>
-                  <a:srgbClr val="404040"/>
+                  <a:srgbClr val="3A2628"/>
                 </a:solidFill>
                 <a:latin typeface="Helvetica Neue" pitchFamily="34" charset="0"/>
                 <a:ea typeface="Helvetica Neue" pitchFamily="34" charset="-122"/>
@@ -10141,11 +10141,11 @@
             <a:avLst/>
           </a:prstGeom>
           <a:solidFill>
-            <a:srgbClr val="F7F7F5"/>
+            <a:srgbClr val="FBF4F5"/>
           </a:solidFill>
           <a:ln w="12700">
             <a:solidFill>
-              <a:srgbClr val="D8D8D5"/>
+              <a:srgbClr val="ECD9DB"/>
             </a:solidFill>
             <a:prstDash val="solid"/>
           </a:ln>
@@ -10166,11 +10166,11 @@
             <a:avLst/>
           </a:prstGeom>
           <a:solidFill>
-            <a:srgbClr val="1A1A1A"/>
+            <a:srgbClr val="B91C1C"/>
           </a:solidFill>
           <a:ln w="12700">
             <a:solidFill>
-              <a:srgbClr val="1A1A1A"/>
+              <a:srgbClr val="1F1213"/>
             </a:solidFill>
             <a:prstDash val="solid"/>
           </a:ln>
@@ -10203,7 +10203,7 @@
             <a:r>
               <a:rPr lang="en-US" sz="1300" b="1" dirty="0">
                 <a:solidFill>
-                  <a:srgbClr val="1A1A1A"/>
+                  <a:srgbClr val="1F1213"/>
                 </a:solidFill>
                 <a:latin typeface="Helvetica Neue" pitchFamily="34" charset="0"/>
                 <a:ea typeface="Helvetica Neue" pitchFamily="34" charset="-122"/>
@@ -10242,7 +10242,7 @@
             <a:r>
               <a:rPr lang="en-US" sz="1100" dirty="0">
                 <a:solidFill>
-                  <a:srgbClr val="5A5A5A"/>
+                  <a:srgbClr val="6B5557"/>
                 </a:solidFill>
                 <a:latin typeface="Helvetica Neue" pitchFamily="34" charset="0"/>
                 <a:ea typeface="Helvetica Neue" pitchFamily="34" charset="-122"/>
@@ -10281,7 +10281,7 @@
             <a:r>
               <a:rPr lang="en-US" sz="1100" dirty="0">
                 <a:solidFill>
-                  <a:srgbClr val="404040"/>
+                  <a:srgbClr val="3A2628"/>
                 </a:solidFill>
                 <a:latin typeface="Helvetica Neue" pitchFamily="34" charset="0"/>
                 <a:ea typeface="Helvetica Neue" pitchFamily="34" charset="-122"/>
@@ -10308,11 +10308,11 @@
             <a:avLst/>
           </a:prstGeom>
           <a:solidFill>
-            <a:srgbClr val="F7F7F5"/>
+            <a:srgbClr val="FBF4F5"/>
           </a:solidFill>
           <a:ln w="12700">
             <a:solidFill>
-              <a:srgbClr val="D8D8D5"/>
+              <a:srgbClr val="ECD9DB"/>
             </a:solidFill>
             <a:prstDash val="solid"/>
           </a:ln>
@@ -10333,11 +10333,11 @@
             <a:avLst/>
           </a:prstGeom>
           <a:solidFill>
-            <a:srgbClr val="1A1A1A"/>
+            <a:srgbClr val="B91C1C"/>
           </a:solidFill>
           <a:ln w="12700">
             <a:solidFill>
-              <a:srgbClr val="1A1A1A"/>
+              <a:srgbClr val="1F1213"/>
             </a:solidFill>
             <a:prstDash val="solid"/>
           </a:ln>
@@ -10370,7 +10370,7 @@
             <a:r>
               <a:rPr lang="en-US" sz="1300" b="1" dirty="0">
                 <a:solidFill>
-                  <a:srgbClr val="1A1A1A"/>
+                  <a:srgbClr val="1F1213"/>
                 </a:solidFill>
                 <a:latin typeface="Helvetica Neue" pitchFamily="34" charset="0"/>
                 <a:ea typeface="Helvetica Neue" pitchFamily="34" charset="-122"/>
@@ -10409,7 +10409,7 @@
             <a:r>
               <a:rPr lang="en-US" sz="1100" dirty="0">
                 <a:solidFill>
-                  <a:srgbClr val="5A5A5A"/>
+                  <a:srgbClr val="6B5557"/>
                 </a:solidFill>
                 <a:latin typeface="Helvetica Neue" pitchFamily="34" charset="0"/>
                 <a:ea typeface="Helvetica Neue" pitchFamily="34" charset="-122"/>
@@ -10448,7 +10448,7 @@
             <a:r>
               <a:rPr lang="en-US" sz="1100" dirty="0">
                 <a:solidFill>
-                  <a:srgbClr val="404040"/>
+                  <a:srgbClr val="3A2628"/>
                 </a:solidFill>
                 <a:latin typeface="Helvetica Neue" pitchFamily="34" charset="0"/>
                 <a:ea typeface="Helvetica Neue" pitchFamily="34" charset="-122"/>
@@ -10475,11 +10475,11 @@
             <a:avLst/>
           </a:prstGeom>
           <a:solidFill>
-            <a:srgbClr val="F7F7F5"/>
+            <a:srgbClr val="FBF4F5"/>
           </a:solidFill>
           <a:ln w="12700">
             <a:solidFill>
-              <a:srgbClr val="D8D8D5"/>
+              <a:srgbClr val="ECD9DB"/>
             </a:solidFill>
             <a:prstDash val="solid"/>
           </a:ln>
@@ -10500,11 +10500,11 @@
             <a:avLst/>
           </a:prstGeom>
           <a:solidFill>
-            <a:srgbClr val="1A1A1A"/>
+            <a:srgbClr val="B91C1C"/>
           </a:solidFill>
           <a:ln w="12700">
             <a:solidFill>
-              <a:srgbClr val="1A1A1A"/>
+              <a:srgbClr val="1F1213"/>
             </a:solidFill>
             <a:prstDash val="solid"/>
           </a:ln>
@@ -10537,7 +10537,7 @@
             <a:r>
               <a:rPr lang="en-US" sz="1300" b="1" dirty="0">
                 <a:solidFill>
-                  <a:srgbClr val="1A1A1A"/>
+                  <a:srgbClr val="1F1213"/>
                 </a:solidFill>
                 <a:latin typeface="Helvetica Neue" pitchFamily="34" charset="0"/>
                 <a:ea typeface="Helvetica Neue" pitchFamily="34" charset="-122"/>
@@ -10576,7 +10576,7 @@
             <a:r>
               <a:rPr lang="en-US" sz="1100" dirty="0">
                 <a:solidFill>
-                  <a:srgbClr val="5A5A5A"/>
+                  <a:srgbClr val="6B5557"/>
                 </a:solidFill>
                 <a:latin typeface="Helvetica Neue" pitchFamily="34" charset="0"/>
                 <a:ea typeface="Helvetica Neue" pitchFamily="34" charset="-122"/>
@@ -10615,7 +10615,7 @@
             <a:r>
               <a:rPr lang="en-US" sz="1100" dirty="0">
                 <a:solidFill>
-                  <a:srgbClr val="404040"/>
+                  <a:srgbClr val="3A2628"/>
                 </a:solidFill>
                 <a:latin typeface="Helvetica Neue" pitchFamily="34" charset="0"/>
                 <a:ea typeface="Helvetica Neue" pitchFamily="34" charset="-122"/>
@@ -10642,11 +10642,11 @@
             <a:avLst/>
           </a:prstGeom>
           <a:solidFill>
-            <a:srgbClr val="F7F7F5"/>
+            <a:srgbClr val="FBF4F5"/>
           </a:solidFill>
           <a:ln w="12700">
             <a:solidFill>
-              <a:srgbClr val="D8D8D5"/>
+              <a:srgbClr val="ECD9DB"/>
             </a:solidFill>
             <a:prstDash val="solid"/>
           </a:ln>
@@ -10667,11 +10667,11 @@
             <a:avLst/>
           </a:prstGeom>
           <a:solidFill>
-            <a:srgbClr val="1A1A1A"/>
+            <a:srgbClr val="B91C1C"/>
           </a:solidFill>
           <a:ln w="12700">
             <a:solidFill>
-              <a:srgbClr val="1A1A1A"/>
+              <a:srgbClr val="1F1213"/>
             </a:solidFill>
             <a:prstDash val="solid"/>
           </a:ln>
@@ -10704,7 +10704,7 @@
             <a:r>
               <a:rPr lang="en-US" sz="1300" b="1" dirty="0">
                 <a:solidFill>
-                  <a:srgbClr val="1A1A1A"/>
+                  <a:srgbClr val="1F1213"/>
                 </a:solidFill>
                 <a:latin typeface="Helvetica Neue" pitchFamily="34" charset="0"/>
                 <a:ea typeface="Helvetica Neue" pitchFamily="34" charset="-122"/>
@@ -10743,7 +10743,7 @@
             <a:r>
               <a:rPr lang="en-US" sz="1100" dirty="0">
                 <a:solidFill>
-                  <a:srgbClr val="5A5A5A"/>
+                  <a:srgbClr val="6B5557"/>
                 </a:solidFill>
                 <a:latin typeface="Helvetica Neue" pitchFamily="34" charset="0"/>
                 <a:ea typeface="Helvetica Neue" pitchFamily="34" charset="-122"/>
@@ -10782,7 +10782,7 @@
             <a:r>
               <a:rPr lang="en-US" sz="1100" dirty="0">
                 <a:solidFill>
-                  <a:srgbClr val="404040"/>
+                  <a:srgbClr val="3A2628"/>
                 </a:solidFill>
                 <a:latin typeface="Helvetica Neue" pitchFamily="34" charset="0"/>
                 <a:ea typeface="Helvetica Neue" pitchFamily="34" charset="-122"/>
@@ -10821,7 +10821,7 @@
             <a:r>
               <a:rPr lang="en-US" sz="1100" i="1" dirty="0">
                 <a:solidFill>
-                  <a:srgbClr val="8A8A8A"/>
+                  <a:srgbClr val="9A8889"/>
                 </a:solidFill>
                 <a:latin typeface="Helvetica Neue" pitchFamily="34" charset="0"/>
                 <a:ea typeface="Helvetica Neue" pitchFamily="34" charset="-122"/>
@@ -10860,7 +10860,7 @@
             <a:r>
               <a:rPr lang="en-US" sz="900" dirty="0">
                 <a:solidFill>
-                  <a:srgbClr val="8A8A8A"/>
+                  <a:srgbClr val="9A8889"/>
                 </a:solidFill>
                 <a:latin typeface="Helvetica Neue" pitchFamily="34" charset="0"/>
                 <a:ea typeface="Helvetica Neue" pitchFamily="34" charset="-122"/>
@@ -10931,7 +10931,7 @@
             <a:r>
               <a:rPr lang="en-US" sz="900" spc="400" kern="0" dirty="0">
                 <a:solidFill>
-                  <a:srgbClr val="8A8A8A"/>
+                  <a:srgbClr val="9A8889"/>
                 </a:solidFill>
                 <a:latin typeface="Helvetica Neue" pitchFamily="34" charset="0"/>
                 <a:ea typeface="Helvetica Neue" pitchFamily="34" charset="-122"/>
@@ -10970,7 +10970,7 @@
             <a:r>
               <a:rPr lang="en-US" sz="3600" b="1" dirty="0">
                 <a:solidFill>
-                  <a:srgbClr val="1A1A1A"/>
+                  <a:srgbClr val="1F1213"/>
                 </a:solidFill>
                 <a:latin typeface="Helvetica Neue" pitchFamily="34" charset="0"/>
                 <a:ea typeface="Helvetica Neue" pitchFamily="34" charset="-122"/>
@@ -10999,7 +10999,7 @@
           <a:noFill/>
           <a:ln w="19050">
             <a:solidFill>
-              <a:srgbClr val="1A1A1A"/>
+              <a:srgbClr val="B91C1C"/>
             </a:solidFill>
             <a:prstDash val="solid"/>
           </a:ln>
@@ -11032,7 +11032,7 @@
             <a:r>
               <a:rPr lang="en-US" sz="1600" i="1" dirty="0">
                 <a:solidFill>
-                  <a:srgbClr val="5A5A5A"/>
+                  <a:srgbClr val="6B5557"/>
                 </a:solidFill>
                 <a:latin typeface="Helvetica Neue" pitchFamily="34" charset="0"/>
                 <a:ea typeface="Helvetica Neue" pitchFamily="34" charset="-122"/>
@@ -11059,11 +11059,11 @@
             <a:avLst/>
           </a:prstGeom>
           <a:solidFill>
-            <a:srgbClr val="1A1A1A"/>
+            <a:srgbClr val="B91C1C"/>
           </a:solidFill>
           <a:ln w="12700">
             <a:solidFill>
-              <a:srgbClr val="1A1A1A"/>
+              <a:srgbClr val="1F1213"/>
             </a:solidFill>
             <a:prstDash val="solid"/>
           </a:ln>
@@ -11096,7 +11096,7 @@
             <a:r>
               <a:rPr lang="en-US" sz="1400" b="1" dirty="0">
                 <a:solidFill>
-                  <a:srgbClr val="1A1A1A"/>
+                  <a:srgbClr val="1F1213"/>
                 </a:solidFill>
                 <a:latin typeface="Helvetica Neue" pitchFamily="34" charset="0"/>
                 <a:ea typeface="Helvetica Neue" pitchFamily="34" charset="-122"/>
@@ -11110,7 +11110,7 @@
             <a:r>
               <a:rPr lang="en-US" sz="1400" dirty="0">
                 <a:solidFill>
-                  <a:srgbClr val="404040"/>
+                  <a:srgbClr val="3A2628"/>
                 </a:solidFill>
                 <a:latin typeface="Helvetica Neue" pitchFamily="34" charset="0"/>
                 <a:ea typeface="Helvetica Neue" pitchFamily="34" charset="-122"/>
@@ -11137,11 +11137,11 @@
             <a:avLst/>
           </a:prstGeom>
           <a:solidFill>
-            <a:srgbClr val="1A1A1A"/>
+            <a:srgbClr val="B91C1C"/>
           </a:solidFill>
           <a:ln w="12700">
             <a:solidFill>
-              <a:srgbClr val="1A1A1A"/>
+              <a:srgbClr val="1F1213"/>
             </a:solidFill>
             <a:prstDash val="solid"/>
           </a:ln>
@@ -11174,7 +11174,7 @@
             <a:r>
               <a:rPr lang="en-US" sz="1400" b="1" dirty="0">
                 <a:solidFill>
-                  <a:srgbClr val="1A1A1A"/>
+                  <a:srgbClr val="1F1213"/>
                 </a:solidFill>
                 <a:latin typeface="Helvetica Neue" pitchFamily="34" charset="0"/>
                 <a:ea typeface="Helvetica Neue" pitchFamily="34" charset="-122"/>
@@ -11188,7 +11188,7 @@
             <a:r>
               <a:rPr lang="en-US" sz="1400" dirty="0">
                 <a:solidFill>
-                  <a:srgbClr val="404040"/>
+                  <a:srgbClr val="3A2628"/>
                 </a:solidFill>
                 <a:latin typeface="Helvetica Neue" pitchFamily="34" charset="0"/>
                 <a:ea typeface="Helvetica Neue" pitchFamily="34" charset="-122"/>
@@ -11215,11 +11215,11 @@
             <a:avLst/>
           </a:prstGeom>
           <a:solidFill>
-            <a:srgbClr val="1A1A1A"/>
+            <a:srgbClr val="B91C1C"/>
           </a:solidFill>
           <a:ln w="12700">
             <a:solidFill>
-              <a:srgbClr val="1A1A1A"/>
+              <a:srgbClr val="1F1213"/>
             </a:solidFill>
             <a:prstDash val="solid"/>
           </a:ln>
@@ -11252,7 +11252,7 @@
             <a:r>
               <a:rPr lang="en-US" sz="1400" b="1" dirty="0">
                 <a:solidFill>
-                  <a:srgbClr val="1A1A1A"/>
+                  <a:srgbClr val="1F1213"/>
                 </a:solidFill>
                 <a:latin typeface="Helvetica Neue" pitchFamily="34" charset="0"/>
                 <a:ea typeface="Helvetica Neue" pitchFamily="34" charset="-122"/>
@@ -11266,7 +11266,7 @@
             <a:r>
               <a:rPr lang="en-US" sz="1400" dirty="0">
                 <a:solidFill>
-                  <a:srgbClr val="404040"/>
+                  <a:srgbClr val="3A2628"/>
                 </a:solidFill>
                 <a:latin typeface="Helvetica Neue" pitchFamily="34" charset="0"/>
                 <a:ea typeface="Helvetica Neue" pitchFamily="34" charset="-122"/>
@@ -11293,11 +11293,11 @@
             <a:avLst/>
           </a:prstGeom>
           <a:solidFill>
-            <a:srgbClr val="1A1A1A"/>
+            <a:srgbClr val="B91C1C"/>
           </a:solidFill>
           <a:ln w="12700">
             <a:solidFill>
-              <a:srgbClr val="1A1A1A"/>
+              <a:srgbClr val="1F1213"/>
             </a:solidFill>
             <a:prstDash val="solid"/>
           </a:ln>
@@ -11330,7 +11330,7 @@
             <a:r>
               <a:rPr lang="en-US" sz="1400" b="1" dirty="0">
                 <a:solidFill>
-                  <a:srgbClr val="1A1A1A"/>
+                  <a:srgbClr val="1F1213"/>
                 </a:solidFill>
                 <a:latin typeface="Helvetica Neue" pitchFamily="34" charset="0"/>
                 <a:ea typeface="Helvetica Neue" pitchFamily="34" charset="-122"/>
@@ -11344,7 +11344,7 @@
             <a:r>
               <a:rPr lang="en-US" sz="1400" dirty="0">
                 <a:solidFill>
-                  <a:srgbClr val="404040"/>
+                  <a:srgbClr val="3A2628"/>
                 </a:solidFill>
                 <a:latin typeface="Helvetica Neue" pitchFamily="34" charset="0"/>
                 <a:ea typeface="Helvetica Neue" pitchFamily="34" charset="-122"/>
@@ -11383,7 +11383,7 @@
             <a:r>
               <a:rPr lang="en-US" sz="1200" i="1" dirty="0">
                 <a:solidFill>
-                  <a:srgbClr val="8A8A8A"/>
+                  <a:srgbClr val="9A8889"/>
                 </a:solidFill>
                 <a:latin typeface="Helvetica Neue" pitchFamily="34" charset="0"/>
                 <a:ea typeface="Helvetica Neue" pitchFamily="34" charset="-122"/>
@@ -11422,7 +11422,7 @@
             <a:r>
               <a:rPr lang="en-US" sz="900" dirty="0">
                 <a:solidFill>
-                  <a:srgbClr val="8A8A8A"/>
+                  <a:srgbClr val="9A8889"/>
                 </a:solidFill>
                 <a:latin typeface="Helvetica Neue" pitchFamily="34" charset="0"/>
                 <a:ea typeface="Helvetica Neue" pitchFamily="34" charset="-122"/>
@@ -11493,7 +11493,7 @@
             <a:r>
               <a:rPr lang="en-US" sz="900" spc="400" kern="0" dirty="0">
                 <a:solidFill>
-                  <a:srgbClr val="8A8A8A"/>
+                  <a:srgbClr val="9A8889"/>
                 </a:solidFill>
                 <a:latin typeface="Helvetica Neue" pitchFamily="34" charset="0"/>
                 <a:ea typeface="Helvetica Neue" pitchFamily="34" charset="-122"/>
@@ -11532,7 +11532,7 @@
             <a:r>
               <a:rPr lang="en-US" sz="3600" b="1" dirty="0">
                 <a:solidFill>
-                  <a:srgbClr val="1A1A1A"/>
+                  <a:srgbClr val="1F1213"/>
                 </a:solidFill>
                 <a:latin typeface="Helvetica Neue" pitchFamily="34" charset="0"/>
                 <a:ea typeface="Helvetica Neue" pitchFamily="34" charset="-122"/>
@@ -11561,7 +11561,7 @@
           <a:noFill/>
           <a:ln w="19050">
             <a:solidFill>
-              <a:srgbClr val="1A1A1A"/>
+              <a:srgbClr val="B91C1C"/>
             </a:solidFill>
             <a:prstDash val="solid"/>
           </a:ln>
@@ -11594,7 +11594,7 @@
             <a:r>
               <a:rPr lang="en-US" sz="1600" i="1" dirty="0">
                 <a:solidFill>
-                  <a:srgbClr val="5A5A5A"/>
+                  <a:srgbClr val="6B5557"/>
                 </a:solidFill>
                 <a:latin typeface="Helvetica Neue" pitchFamily="34" charset="0"/>
                 <a:ea typeface="Helvetica Neue" pitchFamily="34" charset="-122"/>
@@ -11621,11 +11621,11 @@
             <a:avLst/>
           </a:prstGeom>
           <a:solidFill>
-            <a:srgbClr val="1A1A1A"/>
+            <a:srgbClr val="B91C1C"/>
           </a:solidFill>
           <a:ln w="12700">
             <a:solidFill>
-              <a:srgbClr val="1A1A1A"/>
+              <a:srgbClr val="1F1213"/>
             </a:solidFill>
             <a:prstDash val="solid"/>
           </a:ln>
@@ -11658,7 +11658,7 @@
             <a:r>
               <a:rPr lang="en-US" sz="1400" b="1" dirty="0">
                 <a:solidFill>
-                  <a:srgbClr val="1A1A1A"/>
+                  <a:srgbClr val="1F1213"/>
                 </a:solidFill>
                 <a:latin typeface="Helvetica Neue" pitchFamily="34" charset="0"/>
                 <a:ea typeface="Helvetica Neue" pitchFamily="34" charset="-122"/>
@@ -11672,7 +11672,7 @@
             <a:r>
               <a:rPr lang="en-US" sz="1400" dirty="0">
                 <a:solidFill>
-                  <a:srgbClr val="404040"/>
+                  <a:srgbClr val="3A2628"/>
                 </a:solidFill>
                 <a:latin typeface="Helvetica Neue" pitchFamily="34" charset="0"/>
                 <a:ea typeface="Helvetica Neue" pitchFamily="34" charset="-122"/>
@@ -11699,11 +11699,11 @@
             <a:avLst/>
           </a:prstGeom>
           <a:solidFill>
-            <a:srgbClr val="1A1A1A"/>
+            <a:srgbClr val="B91C1C"/>
           </a:solidFill>
           <a:ln w="12700">
             <a:solidFill>
-              <a:srgbClr val="1A1A1A"/>
+              <a:srgbClr val="1F1213"/>
             </a:solidFill>
             <a:prstDash val="solid"/>
           </a:ln>
@@ -11736,7 +11736,7 @@
             <a:r>
               <a:rPr lang="en-US" sz="1400" b="1" dirty="0">
                 <a:solidFill>
-                  <a:srgbClr val="1A1A1A"/>
+                  <a:srgbClr val="1F1213"/>
                 </a:solidFill>
                 <a:latin typeface="Helvetica Neue" pitchFamily="34" charset="0"/>
                 <a:ea typeface="Helvetica Neue" pitchFamily="34" charset="-122"/>
@@ -11750,7 +11750,7 @@
             <a:r>
               <a:rPr lang="en-US" sz="1400" dirty="0">
                 <a:solidFill>
-                  <a:srgbClr val="404040"/>
+                  <a:srgbClr val="3A2628"/>
                 </a:solidFill>
                 <a:latin typeface="Helvetica Neue" pitchFamily="34" charset="0"/>
                 <a:ea typeface="Helvetica Neue" pitchFamily="34" charset="-122"/>
@@ -11777,11 +11777,11 @@
             <a:avLst/>
           </a:prstGeom>
           <a:solidFill>
-            <a:srgbClr val="1A1A1A"/>
+            <a:srgbClr val="B91C1C"/>
           </a:solidFill>
           <a:ln w="12700">
             <a:solidFill>
-              <a:srgbClr val="1A1A1A"/>
+              <a:srgbClr val="1F1213"/>
             </a:solidFill>
             <a:prstDash val="solid"/>
           </a:ln>
@@ -11814,7 +11814,7 @@
             <a:r>
               <a:rPr lang="en-US" sz="1400" b="1" dirty="0">
                 <a:solidFill>
-                  <a:srgbClr val="1A1A1A"/>
+                  <a:srgbClr val="1F1213"/>
                 </a:solidFill>
                 <a:latin typeface="Helvetica Neue" pitchFamily="34" charset="0"/>
                 <a:ea typeface="Helvetica Neue" pitchFamily="34" charset="-122"/>
@@ -11828,7 +11828,7 @@
             <a:r>
               <a:rPr lang="en-US" sz="1400" dirty="0">
                 <a:solidFill>
-                  <a:srgbClr val="404040"/>
+                  <a:srgbClr val="3A2628"/>
                 </a:solidFill>
                 <a:latin typeface="Helvetica Neue" pitchFamily="34" charset="0"/>
                 <a:ea typeface="Helvetica Neue" pitchFamily="34" charset="-122"/>
@@ -11855,11 +11855,11 @@
             <a:avLst/>
           </a:prstGeom>
           <a:solidFill>
-            <a:srgbClr val="1A1A1A"/>
+            <a:srgbClr val="B91C1C"/>
           </a:solidFill>
           <a:ln w="12700">
             <a:solidFill>
-              <a:srgbClr val="1A1A1A"/>
+              <a:srgbClr val="1F1213"/>
             </a:solidFill>
             <a:prstDash val="solid"/>
           </a:ln>
@@ -11892,7 +11892,7 @@
             <a:r>
               <a:rPr lang="en-US" sz="1400" b="1" dirty="0">
                 <a:solidFill>
-                  <a:srgbClr val="1A1A1A"/>
+                  <a:srgbClr val="1F1213"/>
                 </a:solidFill>
                 <a:latin typeface="Helvetica Neue" pitchFamily="34" charset="0"/>
                 <a:ea typeface="Helvetica Neue" pitchFamily="34" charset="-122"/>
@@ -11906,7 +11906,7 @@
             <a:r>
               <a:rPr lang="en-US" sz="1400" dirty="0">
                 <a:solidFill>
-                  <a:srgbClr val="404040"/>
+                  <a:srgbClr val="3A2628"/>
                 </a:solidFill>
                 <a:latin typeface="Helvetica Neue" pitchFamily="34" charset="0"/>
                 <a:ea typeface="Helvetica Neue" pitchFamily="34" charset="-122"/>
@@ -11945,7 +11945,7 @@
             <a:r>
               <a:rPr lang="en-US" sz="1200" i="1" dirty="0">
                 <a:solidFill>
-                  <a:srgbClr val="8A8A8A"/>
+                  <a:srgbClr val="9A8889"/>
                 </a:solidFill>
                 <a:latin typeface="Helvetica Neue" pitchFamily="34" charset="0"/>
                 <a:ea typeface="Helvetica Neue" pitchFamily="34" charset="-122"/>
@@ -11984,7 +11984,7 @@
             <a:r>
               <a:rPr lang="en-US" sz="900" dirty="0">
                 <a:solidFill>
-                  <a:srgbClr val="8A8A8A"/>
+                  <a:srgbClr val="9A8889"/>
                 </a:solidFill>
                 <a:latin typeface="Helvetica Neue" pitchFamily="34" charset="0"/>
                 <a:ea typeface="Helvetica Neue" pitchFamily="34" charset="-122"/>
@@ -12055,7 +12055,7 @@
             <a:r>
               <a:rPr lang="en-US" sz="900" spc="400" kern="0" dirty="0">
                 <a:solidFill>
-                  <a:srgbClr val="8A8A8A"/>
+                  <a:srgbClr val="9A8889"/>
                 </a:solidFill>
                 <a:latin typeface="Helvetica Neue" pitchFamily="34" charset="0"/>
                 <a:ea typeface="Helvetica Neue" pitchFamily="34" charset="-122"/>
@@ -12094,7 +12094,7 @@
             <a:r>
               <a:rPr lang="en-US" sz="3600" b="1" dirty="0">
                 <a:solidFill>
-                  <a:srgbClr val="1A1A1A"/>
+                  <a:srgbClr val="1F1213"/>
                 </a:solidFill>
                 <a:latin typeface="Helvetica Neue" pitchFamily="34" charset="0"/>
                 <a:ea typeface="Helvetica Neue" pitchFamily="34" charset="-122"/>
@@ -12123,7 +12123,7 @@
           <a:noFill/>
           <a:ln w="19050">
             <a:solidFill>
-              <a:srgbClr val="1A1A1A"/>
+              <a:srgbClr val="B91C1C"/>
             </a:solidFill>
             <a:prstDash val="solid"/>
           </a:ln>
@@ -12156,7 +12156,7 @@
             <a:r>
               <a:rPr lang="en-US" sz="1600" i="1" dirty="0">
                 <a:solidFill>
-                  <a:srgbClr val="5A5A5A"/>
+                  <a:srgbClr val="6B5557"/>
                 </a:solidFill>
                 <a:latin typeface="Helvetica Neue" pitchFamily="34" charset="0"/>
                 <a:ea typeface="Helvetica Neue" pitchFamily="34" charset="-122"/>
@@ -12183,11 +12183,11 @@
             <a:avLst/>
           </a:prstGeom>
           <a:solidFill>
-            <a:srgbClr val="1A1A1A"/>
+            <a:srgbClr val="B91C1C"/>
           </a:solidFill>
           <a:ln w="12700">
             <a:solidFill>
-              <a:srgbClr val="1A1A1A"/>
+              <a:srgbClr val="1F1213"/>
             </a:solidFill>
             <a:prstDash val="solid"/>
           </a:ln>
@@ -12220,7 +12220,7 @@
             <a:r>
               <a:rPr lang="en-US" sz="1400" b="1" dirty="0">
                 <a:solidFill>
-                  <a:srgbClr val="1A1A1A"/>
+                  <a:srgbClr val="1F1213"/>
                 </a:solidFill>
                 <a:latin typeface="Helvetica Neue" pitchFamily="34" charset="0"/>
                 <a:ea typeface="Helvetica Neue" pitchFamily="34" charset="-122"/>
@@ -12234,7 +12234,7 @@
             <a:r>
               <a:rPr lang="en-US" sz="1400" dirty="0">
                 <a:solidFill>
-                  <a:srgbClr val="404040"/>
+                  <a:srgbClr val="3A2628"/>
                 </a:solidFill>
                 <a:latin typeface="Helvetica Neue" pitchFamily="34" charset="0"/>
                 <a:ea typeface="Helvetica Neue" pitchFamily="34" charset="-122"/>
@@ -12261,11 +12261,11 @@
             <a:avLst/>
           </a:prstGeom>
           <a:solidFill>
-            <a:srgbClr val="1A1A1A"/>
+            <a:srgbClr val="B91C1C"/>
           </a:solidFill>
           <a:ln w="12700">
             <a:solidFill>
-              <a:srgbClr val="1A1A1A"/>
+              <a:srgbClr val="1F1213"/>
             </a:solidFill>
             <a:prstDash val="solid"/>
           </a:ln>
@@ -12298,7 +12298,7 @@
             <a:r>
               <a:rPr lang="en-US" sz="1400" b="1" dirty="0">
                 <a:solidFill>
-                  <a:srgbClr val="1A1A1A"/>
+                  <a:srgbClr val="1F1213"/>
                 </a:solidFill>
                 <a:latin typeface="Helvetica Neue" pitchFamily="34" charset="0"/>
                 <a:ea typeface="Helvetica Neue" pitchFamily="34" charset="-122"/>
@@ -12312,7 +12312,7 @@
             <a:r>
               <a:rPr lang="en-US" sz="1400" dirty="0">
                 <a:solidFill>
-                  <a:srgbClr val="404040"/>
+                  <a:srgbClr val="3A2628"/>
                 </a:solidFill>
                 <a:latin typeface="Helvetica Neue" pitchFamily="34" charset="0"/>
                 <a:ea typeface="Helvetica Neue" pitchFamily="34" charset="-122"/>
@@ -12339,11 +12339,11 @@
             <a:avLst/>
           </a:prstGeom>
           <a:solidFill>
-            <a:srgbClr val="1A1A1A"/>
+            <a:srgbClr val="B91C1C"/>
           </a:solidFill>
           <a:ln w="12700">
             <a:solidFill>
-              <a:srgbClr val="1A1A1A"/>
+              <a:srgbClr val="1F1213"/>
             </a:solidFill>
             <a:prstDash val="solid"/>
           </a:ln>
@@ -12376,7 +12376,7 @@
             <a:r>
               <a:rPr lang="en-US" sz="1400" b="1" dirty="0">
                 <a:solidFill>
-                  <a:srgbClr val="1A1A1A"/>
+                  <a:srgbClr val="1F1213"/>
                 </a:solidFill>
                 <a:latin typeface="Helvetica Neue" pitchFamily="34" charset="0"/>
                 <a:ea typeface="Helvetica Neue" pitchFamily="34" charset="-122"/>
@@ -12390,7 +12390,7 @@
             <a:r>
               <a:rPr lang="en-US" sz="1400" dirty="0">
                 <a:solidFill>
-                  <a:srgbClr val="404040"/>
+                  <a:srgbClr val="3A2628"/>
                 </a:solidFill>
                 <a:latin typeface="Helvetica Neue" pitchFamily="34" charset="0"/>
                 <a:ea typeface="Helvetica Neue" pitchFamily="34" charset="-122"/>
@@ -12417,11 +12417,11 @@
             <a:avLst/>
           </a:prstGeom>
           <a:solidFill>
-            <a:srgbClr val="1A1A1A"/>
+            <a:srgbClr val="B91C1C"/>
           </a:solidFill>
           <a:ln w="12700">
             <a:solidFill>
-              <a:srgbClr val="1A1A1A"/>
+              <a:srgbClr val="1F1213"/>
             </a:solidFill>
             <a:prstDash val="solid"/>
           </a:ln>
@@ -12454,7 +12454,7 @@
             <a:r>
               <a:rPr lang="en-US" sz="1400" b="1" dirty="0">
                 <a:solidFill>
-                  <a:srgbClr val="1A1A1A"/>
+                  <a:srgbClr val="1F1213"/>
                 </a:solidFill>
                 <a:latin typeface="Helvetica Neue" pitchFamily="34" charset="0"/>
                 <a:ea typeface="Helvetica Neue" pitchFamily="34" charset="-122"/>
@@ -12468,7 +12468,7 @@
             <a:r>
               <a:rPr lang="en-US" sz="1400" dirty="0">
                 <a:solidFill>
-                  <a:srgbClr val="404040"/>
+                  <a:srgbClr val="3A2628"/>
                 </a:solidFill>
                 <a:latin typeface="Helvetica Neue" pitchFamily="34" charset="0"/>
                 <a:ea typeface="Helvetica Neue" pitchFamily="34" charset="-122"/>
@@ -12507,7 +12507,7 @@
             <a:r>
               <a:rPr lang="en-US" sz="1200" i="1" dirty="0">
                 <a:solidFill>
-                  <a:srgbClr val="8A8A8A"/>
+                  <a:srgbClr val="9A8889"/>
                 </a:solidFill>
                 <a:latin typeface="Helvetica Neue" pitchFamily="34" charset="0"/>
                 <a:ea typeface="Helvetica Neue" pitchFamily="34" charset="-122"/>
@@ -12546,7 +12546,7 @@
             <a:r>
               <a:rPr lang="en-US" sz="900" dirty="0">
                 <a:solidFill>
-                  <a:srgbClr val="8A8A8A"/>
+                  <a:srgbClr val="9A8889"/>
                 </a:solidFill>
                 <a:latin typeface="Helvetica Neue" pitchFamily="34" charset="0"/>
                 <a:ea typeface="Helvetica Neue" pitchFamily="34" charset="-122"/>
@@ -12617,7 +12617,7 @@
             <a:r>
               <a:rPr lang="en-US" sz="900" spc="400" kern="0" dirty="0">
                 <a:solidFill>
-                  <a:srgbClr val="8A8A8A"/>
+                  <a:srgbClr val="9A8889"/>
                 </a:solidFill>
                 <a:latin typeface="Helvetica Neue" pitchFamily="34" charset="0"/>
                 <a:ea typeface="Helvetica Neue" pitchFamily="34" charset="-122"/>
@@ -12656,7 +12656,7 @@
             <a:r>
               <a:rPr lang="en-US" sz="3600" b="1" dirty="0">
                 <a:solidFill>
-                  <a:srgbClr val="1A1A1A"/>
+                  <a:srgbClr val="1F1213"/>
                 </a:solidFill>
                 <a:latin typeface="Helvetica Neue" pitchFamily="34" charset="0"/>
                 <a:ea typeface="Helvetica Neue" pitchFamily="34" charset="-122"/>
@@ -12685,7 +12685,7 @@
           <a:noFill/>
           <a:ln w="19050">
             <a:solidFill>
-              <a:srgbClr val="1A1A1A"/>
+              <a:srgbClr val="B91C1C"/>
             </a:solidFill>
             <a:prstDash val="solid"/>
           </a:ln>
@@ -12718,7 +12718,7 @@
             <a:r>
               <a:rPr lang="en-US" sz="1600" i="1" dirty="0">
                 <a:solidFill>
-                  <a:srgbClr val="5A5A5A"/>
+                  <a:srgbClr val="6B5557"/>
                 </a:solidFill>
                 <a:latin typeface="Helvetica Neue" pitchFamily="34" charset="0"/>
                 <a:ea typeface="Helvetica Neue" pitchFamily="34" charset="-122"/>
@@ -12745,11 +12745,11 @@
             <a:avLst/>
           </a:prstGeom>
           <a:solidFill>
-            <a:srgbClr val="1A1A1A"/>
+            <a:srgbClr val="B91C1C"/>
           </a:solidFill>
           <a:ln w="12700">
             <a:solidFill>
-              <a:srgbClr val="1A1A1A"/>
+              <a:srgbClr val="1F1213"/>
             </a:solidFill>
             <a:prstDash val="solid"/>
           </a:ln>
@@ -12782,7 +12782,7 @@
             <a:r>
               <a:rPr lang="en-US" sz="1400" b="1" dirty="0">
                 <a:solidFill>
-                  <a:srgbClr val="1A1A1A"/>
+                  <a:srgbClr val="1F1213"/>
                 </a:solidFill>
                 <a:latin typeface="Helvetica Neue" pitchFamily="34" charset="0"/>
                 <a:ea typeface="Helvetica Neue" pitchFamily="34" charset="-122"/>
@@ -12796,7 +12796,7 @@
             <a:r>
               <a:rPr lang="en-US" sz="1400" dirty="0">
                 <a:solidFill>
-                  <a:srgbClr val="404040"/>
+                  <a:srgbClr val="3A2628"/>
                 </a:solidFill>
                 <a:latin typeface="Helvetica Neue" pitchFamily="34" charset="0"/>
                 <a:ea typeface="Helvetica Neue" pitchFamily="34" charset="-122"/>
@@ -12823,11 +12823,11 @@
             <a:avLst/>
           </a:prstGeom>
           <a:solidFill>
-            <a:srgbClr val="1A1A1A"/>
+            <a:srgbClr val="B91C1C"/>
           </a:solidFill>
           <a:ln w="12700">
             <a:solidFill>
-              <a:srgbClr val="1A1A1A"/>
+              <a:srgbClr val="1F1213"/>
             </a:solidFill>
             <a:prstDash val="solid"/>
           </a:ln>
@@ -12860,7 +12860,7 @@
             <a:r>
               <a:rPr lang="en-US" sz="1400" b="1" dirty="0">
                 <a:solidFill>
-                  <a:srgbClr val="1A1A1A"/>
+                  <a:srgbClr val="1F1213"/>
                 </a:solidFill>
                 <a:latin typeface="Helvetica Neue" pitchFamily="34" charset="0"/>
                 <a:ea typeface="Helvetica Neue" pitchFamily="34" charset="-122"/>
@@ -12874,7 +12874,7 @@
             <a:r>
               <a:rPr lang="en-US" sz="1400" dirty="0">
                 <a:solidFill>
-                  <a:srgbClr val="404040"/>
+                  <a:srgbClr val="3A2628"/>
                 </a:solidFill>
                 <a:latin typeface="Helvetica Neue" pitchFamily="34" charset="0"/>
                 <a:ea typeface="Helvetica Neue" pitchFamily="34" charset="-122"/>
@@ -12901,11 +12901,11 @@
             <a:avLst/>
           </a:prstGeom>
           <a:solidFill>
-            <a:srgbClr val="1A1A1A"/>
+            <a:srgbClr val="B91C1C"/>
           </a:solidFill>
           <a:ln w="12700">
             <a:solidFill>
-              <a:srgbClr val="1A1A1A"/>
+              <a:srgbClr val="1F1213"/>
             </a:solidFill>
             <a:prstDash val="solid"/>
           </a:ln>
@@ -12938,7 +12938,7 @@
             <a:r>
               <a:rPr lang="en-US" sz="1400" b="1" dirty="0">
                 <a:solidFill>
-                  <a:srgbClr val="1A1A1A"/>
+                  <a:srgbClr val="1F1213"/>
                 </a:solidFill>
                 <a:latin typeface="Helvetica Neue" pitchFamily="34" charset="0"/>
                 <a:ea typeface="Helvetica Neue" pitchFamily="34" charset="-122"/>
@@ -12952,7 +12952,7 @@
             <a:r>
               <a:rPr lang="en-US" sz="1400" dirty="0">
                 <a:solidFill>
-                  <a:srgbClr val="404040"/>
+                  <a:srgbClr val="3A2628"/>
                 </a:solidFill>
                 <a:latin typeface="Helvetica Neue" pitchFamily="34" charset="0"/>
                 <a:ea typeface="Helvetica Neue" pitchFamily="34" charset="-122"/>
@@ -12979,11 +12979,11 @@
             <a:avLst/>
           </a:prstGeom>
           <a:solidFill>
-            <a:srgbClr val="1A1A1A"/>
+            <a:srgbClr val="B91C1C"/>
           </a:solidFill>
           <a:ln w="12700">
             <a:solidFill>
-              <a:srgbClr val="1A1A1A"/>
+              <a:srgbClr val="1F1213"/>
             </a:solidFill>
             <a:prstDash val="solid"/>
           </a:ln>
@@ -13016,7 +13016,7 @@
             <a:r>
               <a:rPr lang="en-US" sz="1400" b="1" dirty="0">
                 <a:solidFill>
-                  <a:srgbClr val="1A1A1A"/>
+                  <a:srgbClr val="1F1213"/>
                 </a:solidFill>
                 <a:latin typeface="Helvetica Neue" pitchFamily="34" charset="0"/>
                 <a:ea typeface="Helvetica Neue" pitchFamily="34" charset="-122"/>
@@ -13030,7 +13030,7 @@
             <a:r>
               <a:rPr lang="en-US" sz="1400" dirty="0">
                 <a:solidFill>
-                  <a:srgbClr val="404040"/>
+                  <a:srgbClr val="3A2628"/>
                 </a:solidFill>
                 <a:latin typeface="Helvetica Neue" pitchFamily="34" charset="0"/>
                 <a:ea typeface="Helvetica Neue" pitchFamily="34" charset="-122"/>
@@ -13069,7 +13069,7 @@
             <a:r>
               <a:rPr lang="en-US" sz="1200" i="1" dirty="0">
                 <a:solidFill>
-                  <a:srgbClr val="8A8A8A"/>
+                  <a:srgbClr val="9A8889"/>
                 </a:solidFill>
                 <a:latin typeface="Helvetica Neue" pitchFamily="34" charset="0"/>
                 <a:ea typeface="Helvetica Neue" pitchFamily="34" charset="-122"/>
@@ -13108,7 +13108,7 @@
             <a:r>
               <a:rPr lang="en-US" sz="900" dirty="0">
                 <a:solidFill>
-                  <a:srgbClr val="8A8A8A"/>
+                  <a:srgbClr val="9A8889"/>
                 </a:solidFill>
                 <a:latin typeface="Helvetica Neue" pitchFamily="34" charset="0"/>
                 <a:ea typeface="Helvetica Neue" pitchFamily="34" charset="-122"/>

</xml_diff>